<commit_message>
read the ppt of class 2, translated to engligh
</commit_message>
<xml_diff>
--- a/slides/2_deploy-model_azure/2-Train and deploy ML models.pptx
+++ b/slides/2_deploy-model_azure/2-Train and deploy ML models.pptx
@@ -214,7 +214,7 @@
           <a:p>
             <a:fld id="{9357E7CD-833A-4057-A34F-721214C10A5F}" type="datetimeFigureOut">
               <a:rPr lang="fr-FR" smtClean="0"/>
-              <a:t>30/04/2025</a:t>
+              <a:t>06/05/2025</a:t>
             </a:fld>
             <a:endParaRPr lang="fr-FR"/>
           </a:p>
@@ -480,6 +480,234 @@
     </a:lvl9pPr>
   </p:notesStyle>
 </p:notesMaster>
+</file>
+
+<file path=ppt/notesSlides/notesSlide1.xml><?xml version="1.0" encoding="utf-8"?>
+<p:notes xmlns:a="http://schemas.openxmlformats.org/drawingml/2006/main" xmlns:r="http://schemas.openxmlformats.org/officeDocument/2006/relationships" xmlns:p="http://schemas.openxmlformats.org/presentationml/2006/main">
+  <p:cSld>
+    <p:spTree>
+      <p:nvGrpSpPr>
+        <p:cNvPr id="1" name=""/>
+        <p:cNvGrpSpPr/>
+        <p:nvPr/>
+      </p:nvGrpSpPr>
+      <p:grpSpPr>
+        <a:xfrm>
+          <a:off x="0" y="0"/>
+          <a:ext cx="0" cy="0"/>
+          <a:chOff x="0" y="0"/>
+          <a:chExt cx="0" cy="0"/>
+        </a:xfrm>
+      </p:grpSpPr>
+      <p:sp>
+        <p:nvSpPr>
+          <p:cNvPr id="2" name="Espace réservé de l'image des diapositives 1"/>
+          <p:cNvSpPr>
+            <a:spLocks noGrp="1" noRot="1" noChangeAspect="1"/>
+          </p:cNvSpPr>
+          <p:nvPr>
+            <p:ph type="sldImg"/>
+          </p:nvPr>
+        </p:nvSpPr>
+        <p:spPr/>
+      </p:sp>
+      <p:sp>
+        <p:nvSpPr>
+          <p:cNvPr id="3" name="Espace réservé des notes 2"/>
+          <p:cNvSpPr>
+            <a:spLocks noGrp="1"/>
+          </p:cNvSpPr>
+          <p:nvPr>
+            <p:ph type="body" idx="1"/>
+          </p:nvPr>
+        </p:nvSpPr>
+        <p:spPr/>
+        <p:txBody>
+          <a:bodyPr/>
+          <a:lstStyle/>
+          <a:p>
+            <a:r>
+              <a:rPr lang="fr-FR" dirty="0" err="1" smtClean="0"/>
+              <a:t>Added</a:t>
+            </a:r>
+            <a:r>
+              <a:rPr lang="fr-FR" dirty="0" smtClean="0"/>
+              <a:t> </a:t>
+            </a:r>
+            <a:r>
+              <a:rPr lang="fr-FR" dirty="0" err="1" smtClean="0"/>
+              <a:t>market</a:t>
+            </a:r>
+            <a:r>
+              <a:rPr lang="fr-FR" dirty="0" smtClean="0"/>
+              <a:t> </a:t>
+            </a:r>
+            <a:r>
+              <a:rPr lang="fr-FR" dirty="0" err="1" smtClean="0"/>
+              <a:t>share</a:t>
+            </a:r>
+            <a:endParaRPr lang="fr-FR" dirty="0"/>
+          </a:p>
+        </p:txBody>
+      </p:sp>
+      <p:sp>
+        <p:nvSpPr>
+          <p:cNvPr id="4" name="Espace réservé du numéro de diapositive 3"/>
+          <p:cNvSpPr>
+            <a:spLocks noGrp="1"/>
+          </p:cNvSpPr>
+          <p:nvPr>
+            <p:ph type="sldNum" sz="quarter" idx="10"/>
+          </p:nvPr>
+        </p:nvSpPr>
+        <p:spPr/>
+        <p:txBody>
+          <a:bodyPr/>
+          <a:lstStyle/>
+          <a:p>
+            <a:fld id="{F6BF3BD9-BA5A-4CBB-9C78-D323B9124BDA}" type="slidenum">
+              <a:rPr lang="fr-FR" smtClean="0"/>
+              <a:t>5</a:t>
+            </a:fld>
+            <a:endParaRPr lang="fr-FR"/>
+          </a:p>
+        </p:txBody>
+      </p:sp>
+    </p:spTree>
+    <p:extLst>
+      <p:ext uri="{BB962C8B-B14F-4D97-AF65-F5344CB8AC3E}">
+        <p14:creationId xmlns:p14="http://schemas.microsoft.com/office/powerpoint/2010/main" val="3588924268"/>
+      </p:ext>
+    </p:extLst>
+  </p:cSld>
+  <p:clrMapOvr>
+    <a:masterClrMapping/>
+  </p:clrMapOvr>
+</p:notes>
+</file>
+
+<file path=ppt/notesSlides/notesSlide2.xml><?xml version="1.0" encoding="utf-8"?>
+<p:notes xmlns:a="http://schemas.openxmlformats.org/drawingml/2006/main" xmlns:r="http://schemas.openxmlformats.org/officeDocument/2006/relationships" xmlns:p="http://schemas.openxmlformats.org/presentationml/2006/main">
+  <p:cSld>
+    <p:spTree>
+      <p:nvGrpSpPr>
+        <p:cNvPr id="1" name=""/>
+        <p:cNvGrpSpPr/>
+        <p:nvPr/>
+      </p:nvGrpSpPr>
+      <p:grpSpPr>
+        <a:xfrm>
+          <a:off x="0" y="0"/>
+          <a:ext cx="0" cy="0"/>
+          <a:chOff x="0" y="0"/>
+          <a:chExt cx="0" cy="0"/>
+        </a:xfrm>
+      </p:grpSpPr>
+      <p:sp>
+        <p:nvSpPr>
+          <p:cNvPr id="2" name="Espace réservé de l'image des diapositives 1"/>
+          <p:cNvSpPr>
+            <a:spLocks noGrp="1" noRot="1" noChangeAspect="1"/>
+          </p:cNvSpPr>
+          <p:nvPr>
+            <p:ph type="sldImg"/>
+          </p:nvPr>
+        </p:nvSpPr>
+        <p:spPr/>
+      </p:sp>
+      <p:sp>
+        <p:nvSpPr>
+          <p:cNvPr id="3" name="Espace réservé des notes 2"/>
+          <p:cNvSpPr>
+            <a:spLocks noGrp="1"/>
+          </p:cNvSpPr>
+          <p:nvPr>
+            <p:ph type="body" idx="1"/>
+          </p:nvPr>
+        </p:nvSpPr>
+        <p:spPr/>
+        <p:txBody>
+          <a:bodyPr/>
+          <a:lstStyle/>
+          <a:p>
+            <a:r>
+              <a:rPr lang="fr-FR" dirty="0" err="1" smtClean="0"/>
+              <a:t>Added</a:t>
+            </a:r>
+            <a:r>
+              <a:rPr lang="fr-FR" dirty="0" smtClean="0"/>
+              <a:t> « not to </a:t>
+            </a:r>
+            <a:r>
+              <a:rPr lang="fr-FR" dirty="0" err="1" smtClean="0"/>
+              <a:t>be</a:t>
+            </a:r>
+            <a:r>
+              <a:rPr lang="fr-FR" dirty="0" smtClean="0"/>
+              <a:t> </a:t>
+            </a:r>
+            <a:r>
+              <a:rPr lang="fr-FR" dirty="0" err="1" smtClean="0"/>
+              <a:t>confused</a:t>
+            </a:r>
+            <a:r>
+              <a:rPr lang="fr-FR" dirty="0" smtClean="0"/>
+              <a:t> </a:t>
+            </a:r>
+            <a:r>
+              <a:rPr lang="fr-FR" dirty="0" err="1" smtClean="0"/>
+              <a:t>with</a:t>
+            </a:r>
+            <a:r>
+              <a:rPr lang="fr-FR" dirty="0" smtClean="0"/>
+              <a:t> model </a:t>
+            </a:r>
+            <a:r>
+              <a:rPr lang="fr-FR" dirty="0" err="1" smtClean="0"/>
+              <a:t>parameters</a:t>
+            </a:r>
+            <a:r>
+              <a:rPr lang="fr-FR" dirty="0" smtClean="0"/>
+              <a:t> [… ]»</a:t>
+            </a:r>
+            <a:endParaRPr lang="fr-FR" dirty="0"/>
+          </a:p>
+        </p:txBody>
+      </p:sp>
+      <p:sp>
+        <p:nvSpPr>
+          <p:cNvPr id="4" name="Espace réservé du numéro de diapositive 3"/>
+          <p:cNvSpPr>
+            <a:spLocks noGrp="1"/>
+          </p:cNvSpPr>
+          <p:nvPr>
+            <p:ph type="sldNum" sz="quarter" idx="10"/>
+          </p:nvPr>
+        </p:nvSpPr>
+        <p:spPr/>
+        <p:txBody>
+          <a:bodyPr/>
+          <a:lstStyle/>
+          <a:p>
+            <a:fld id="{F6BF3BD9-BA5A-4CBB-9C78-D323B9124BDA}" type="slidenum">
+              <a:rPr lang="fr-FR" smtClean="0"/>
+              <a:t>10</a:t>
+            </a:fld>
+            <a:endParaRPr lang="fr-FR"/>
+          </a:p>
+        </p:txBody>
+      </p:sp>
+    </p:spTree>
+    <p:extLst>
+      <p:ext uri="{BB962C8B-B14F-4D97-AF65-F5344CB8AC3E}">
+        <p14:creationId xmlns:p14="http://schemas.microsoft.com/office/powerpoint/2010/main" val="4062474957"/>
+      </p:ext>
+    </p:extLst>
+  </p:cSld>
+  <p:clrMapOvr>
+    <a:masterClrMapping/>
+  </p:clrMapOvr>
+</p:notes>
 </file>
 
 <file path=ppt/slideLayouts/slideLayout1.xml><?xml version="1.0" encoding="utf-8"?>
@@ -12934,19 +13162,35 @@
           <a:p>
             <a:r>
               <a:rPr lang="fr-FR" sz="2800" dirty="0" smtClean="0"/>
-              <a:t>3 – Entraîner et déployer un modèle de ML sur </a:t>
+              <a:t>3 – </a:t>
             </a:r>
             <a:r>
               <a:rPr lang="fr-FR" sz="2800" dirty="0" smtClean="0"/>
-              <a:t>Azure </a:t>
+              <a:t>Train and </a:t>
+            </a:r>
+            <a:r>
+              <a:rPr lang="fr-FR" sz="2800" dirty="0" err="1" smtClean="0"/>
+              <a:t>deploy</a:t>
             </a:r>
             <a:r>
               <a:rPr lang="fr-FR" sz="2800" dirty="0" smtClean="0"/>
-              <a:t>avec </a:t>
+              <a:t> a machine </a:t>
             </a:r>
             <a:r>
               <a:rPr lang="fr-FR" sz="2800" dirty="0" err="1" smtClean="0"/>
-              <a:t>AzureML</a:t>
+              <a:t>learning</a:t>
+            </a:r>
+            <a:r>
+              <a:rPr lang="fr-FR" sz="2800" dirty="0" smtClean="0"/>
+              <a:t> model on Azure </a:t>
+            </a:r>
+            <a:r>
+              <a:rPr lang="fr-FR" sz="2800" dirty="0" err="1" smtClean="0"/>
+              <a:t>with</a:t>
+            </a:r>
+            <a:r>
+              <a:rPr lang="fr-FR" sz="2800" dirty="0" smtClean="0"/>
+              <a:t> Azure ML</a:t>
             </a:r>
             <a:endParaRPr lang="fr-FR" sz="2800" dirty="0"/>
           </a:p>
@@ -12969,7 +13213,23 @@
           <a:p>
             <a:r>
               <a:rPr lang="fr-FR" dirty="0" smtClean="0"/>
-              <a:t>Modèle personnalisé, tâche d’entrainement, inférence de modèle en batch et en streaming, montées en charge d’un </a:t>
+              <a:t>Custom model, training </a:t>
+            </a:r>
+            <a:r>
+              <a:rPr lang="fr-FR" dirty="0" err="1" smtClean="0"/>
+              <a:t>task</a:t>
+            </a:r>
+            <a:r>
+              <a:rPr lang="fr-FR" dirty="0" smtClean="0"/>
+              <a:t>, batch/streaming </a:t>
+            </a:r>
+            <a:r>
+              <a:rPr lang="fr-FR" dirty="0" err="1" smtClean="0"/>
+              <a:t>inference</a:t>
+            </a:r>
+            <a:r>
+              <a:rPr lang="fr-FR" dirty="0" smtClean="0"/>
+              <a:t>, </a:t>
             </a:r>
             <a:r>
               <a:rPr lang="fr-FR" dirty="0" err="1" smtClean="0"/>
@@ -12977,7 +13237,19 @@
             </a:r>
             <a:r>
               <a:rPr lang="fr-FR" dirty="0" smtClean="0"/>
-              <a:t>, A/B </a:t>
+              <a:t> </a:t>
+            </a:r>
+            <a:r>
+              <a:rPr lang="fr-FR" dirty="0" err="1" smtClean="0"/>
+              <a:t>scaling</a:t>
+            </a:r>
+            <a:r>
+              <a:rPr lang="fr-FR" dirty="0" smtClean="0"/>
+              <a:t>, </a:t>
+            </a:r>
+            <a:r>
+              <a:rPr lang="fr-FR" dirty="0" smtClean="0"/>
+              <a:t>A/B </a:t>
             </a:r>
             <a:r>
               <a:rPr lang="fr-FR" dirty="0" err="1" smtClean="0"/>
@@ -13041,15 +13313,15 @@
           <a:p>
             <a:r>
               <a:rPr lang="fr-FR" dirty="0" err="1" smtClean="0"/>
-              <a:t>Tuning</a:t>
+              <a:t>Hyperparameter</a:t>
             </a:r>
             <a:r>
               <a:rPr lang="fr-FR" dirty="0" smtClean="0"/>
-              <a:t> des </a:t>
+              <a:t> </a:t>
             </a:r>
             <a:r>
               <a:rPr lang="fr-FR" dirty="0" err="1" smtClean="0"/>
-              <a:t>hyperparamètres</a:t>
+              <a:t>tuning</a:t>
             </a:r>
             <a:endParaRPr lang="fr-FR" dirty="0"/>
           </a:p>
@@ -13100,8 +13372,20 @@
           <a:lstStyle/>
           <a:p>
             <a:r>
-              <a:rPr lang="en-US" smtClean="0"/>
-              <a:t>2024 | ©HeadMind Partners</a:t>
+              <a:rPr lang="en-US" dirty="0" smtClean="0"/>
+              <a:t>2025 </a:t>
+            </a:r>
+            <a:r>
+              <a:rPr lang="en-US" dirty="0" smtClean="0"/>
+              <a:t>| ©</a:t>
+            </a:r>
+            <a:r>
+              <a:rPr lang="en-US" dirty="0" err="1" smtClean="0"/>
+              <a:t>HeadMind</a:t>
+            </a:r>
+            <a:r>
+              <a:rPr lang="en-US" dirty="0" smtClean="0"/>
+              <a:t> Partners</a:t>
             </a:r>
             <a:endParaRPr lang="fr-FR" dirty="0"/>
           </a:p>
@@ -13126,29 +13410,190 @@
               <a:buNone/>
             </a:pPr>
             <a:r>
+              <a:rPr lang="fr-FR" dirty="0" err="1" smtClean="0"/>
+              <a:t>What’s</a:t>
+            </a:r>
+            <a:r>
               <a:rPr lang="fr-FR" dirty="0" smtClean="0"/>
-              <a:t>Qu’est ce que c’est ?</a:t>
-            </a:r>
-          </a:p>
-          <a:p>
+              <a:t> </a:t>
+            </a:r>
+            <a:r>
+              <a:rPr lang="fr-FR" dirty="0" err="1" smtClean="0"/>
+              <a:t>hyperparameter</a:t>
+            </a:r>
             <a:r>
               <a:rPr lang="fr-FR" dirty="0" smtClean="0"/>
-              <a:t>Optimiser les </a:t>
+              <a:t> </a:t>
+            </a:r>
+            <a:r>
+              <a:rPr lang="fr-FR" dirty="0" err="1" smtClean="0"/>
+              <a:t>tuning</a:t>
+            </a:r>
+            <a:r>
+              <a:rPr lang="fr-FR" dirty="0" smtClean="0"/>
+              <a:t> ?</a:t>
+            </a:r>
+            <a:endParaRPr lang="fr-FR" dirty="0" smtClean="0"/>
+          </a:p>
+          <a:p>
+            <a:r>
+              <a:rPr lang="fr-FR" dirty="0" err="1" smtClean="0"/>
+              <a:t>Aims</a:t>
+            </a:r>
+            <a:r>
+              <a:rPr lang="fr-FR" dirty="0" smtClean="0"/>
+              <a:t> to </a:t>
+            </a:r>
+            <a:r>
+              <a:rPr lang="fr-FR" dirty="0" err="1" smtClean="0"/>
+              <a:t>find</a:t>
+            </a:r>
+            <a:r>
+              <a:rPr lang="fr-FR" dirty="0" smtClean="0"/>
+              <a:t> the best </a:t>
             </a:r>
             <a:r>
               <a:rPr lang="fr-FR" b="1" dirty="0" err="1" smtClean="0"/>
-              <a:t>hyperparamètres</a:t>
+              <a:t>hyperparameters</a:t>
             </a:r>
             <a:r>
               <a:rPr lang="fr-FR" dirty="0" smtClean="0"/>
-              <a:t> d’un modèle (batch size, nombre de neurones…)</a:t>
-            </a:r>
-          </a:p>
-          <a:p>
+              <a:t> of a model </a:t>
+            </a:r>
             <a:r>
               <a:rPr lang="fr-FR" dirty="0" smtClean="0"/>
-              <a:t>Ces modifications vont influencer l’entraînement du modèle</a:t>
-            </a:r>
+              <a:t>(batch size, </a:t>
+            </a:r>
+            <a:r>
+              <a:rPr lang="fr-FR" dirty="0" err="1" smtClean="0"/>
+              <a:t>number</a:t>
+            </a:r>
+            <a:r>
+              <a:rPr lang="fr-FR" dirty="0" smtClean="0"/>
+              <a:t> of </a:t>
+            </a:r>
+            <a:r>
+              <a:rPr lang="fr-FR" dirty="0" err="1" smtClean="0"/>
+              <a:t>hidden</a:t>
+            </a:r>
+            <a:r>
+              <a:rPr lang="fr-FR" dirty="0" smtClean="0"/>
+              <a:t> </a:t>
+            </a:r>
+            <a:r>
+              <a:rPr lang="fr-FR" dirty="0" err="1" smtClean="0"/>
+              <a:t>layers</a:t>
+            </a:r>
+            <a:r>
+              <a:rPr lang="fr-FR" dirty="0" smtClean="0"/>
+              <a:t>…)</a:t>
+            </a:r>
+          </a:p>
+          <a:p>
+            <a:r>
+              <a:rPr lang="fr-FR" dirty="0" smtClean="0"/>
+              <a:t>Not to </a:t>
+            </a:r>
+            <a:r>
+              <a:rPr lang="fr-FR" dirty="0" err="1" smtClean="0"/>
+              <a:t>be</a:t>
+            </a:r>
+            <a:r>
+              <a:rPr lang="fr-FR" dirty="0" smtClean="0"/>
+              <a:t> </a:t>
+            </a:r>
+            <a:r>
+              <a:rPr lang="fr-FR" dirty="0" err="1" smtClean="0"/>
+              <a:t>confused</a:t>
+            </a:r>
+            <a:r>
+              <a:rPr lang="fr-FR" dirty="0" smtClean="0"/>
+              <a:t> </a:t>
+            </a:r>
+            <a:r>
+              <a:rPr lang="fr-FR" dirty="0" err="1" smtClean="0"/>
+              <a:t>with</a:t>
+            </a:r>
+            <a:r>
+              <a:rPr lang="fr-FR" dirty="0" smtClean="0"/>
+              <a:t> model </a:t>
+            </a:r>
+            <a:r>
+              <a:rPr lang="fr-FR" dirty="0" err="1" smtClean="0"/>
+              <a:t>parameters</a:t>
+            </a:r>
+            <a:r>
+              <a:rPr lang="fr-FR" dirty="0" smtClean="0"/>
+              <a:t> (</a:t>
+            </a:r>
+            <a:r>
+              <a:rPr lang="fr-FR" dirty="0" err="1" smtClean="0"/>
+              <a:t>weight</a:t>
+            </a:r>
+            <a:r>
+              <a:rPr lang="fr-FR" dirty="0" smtClean="0"/>
+              <a:t> and </a:t>
+            </a:r>
+            <a:r>
+              <a:rPr lang="fr-FR" dirty="0" err="1" smtClean="0"/>
+              <a:t>bias</a:t>
+            </a:r>
+            <a:r>
+              <a:rPr lang="fr-FR" dirty="0" smtClean="0"/>
+              <a:t> of </a:t>
+            </a:r>
+            <a:r>
+              <a:rPr lang="fr-FR" dirty="0" err="1" smtClean="0"/>
+              <a:t>each</a:t>
+            </a:r>
+            <a:r>
+              <a:rPr lang="fr-FR" dirty="0" smtClean="0"/>
+              <a:t> </a:t>
+            </a:r>
+            <a:r>
+              <a:rPr lang="fr-FR" dirty="0" err="1" smtClean="0"/>
+              <a:t>neuron</a:t>
+            </a:r>
+            <a:r>
+              <a:rPr lang="fr-FR" dirty="0" smtClean="0"/>
+              <a:t>)</a:t>
+            </a:r>
+            <a:endParaRPr lang="fr-FR" dirty="0" smtClean="0"/>
+          </a:p>
+          <a:p>
+            <a:r>
+              <a:rPr lang="fr-FR" dirty="0" err="1" smtClean="0"/>
+              <a:t>These</a:t>
+            </a:r>
+            <a:r>
+              <a:rPr lang="fr-FR" dirty="0" smtClean="0"/>
+              <a:t> high-</a:t>
+            </a:r>
+            <a:r>
+              <a:rPr lang="fr-FR" dirty="0" err="1" smtClean="0"/>
+              <a:t>level</a:t>
+            </a:r>
+            <a:r>
+              <a:rPr lang="fr-FR" dirty="0" smtClean="0"/>
+              <a:t> </a:t>
+            </a:r>
+            <a:r>
+              <a:rPr lang="fr-FR" dirty="0" err="1" smtClean="0"/>
+              <a:t>hyperparameters</a:t>
+            </a:r>
+            <a:r>
+              <a:rPr lang="fr-FR" dirty="0" smtClean="0"/>
+              <a:t> </a:t>
+            </a:r>
+            <a:r>
+              <a:rPr lang="fr-FR" dirty="0" err="1" smtClean="0"/>
+              <a:t>will</a:t>
+            </a:r>
+            <a:r>
+              <a:rPr lang="fr-FR" dirty="0" smtClean="0"/>
+              <a:t> influence model training </a:t>
+            </a:r>
+            <a:endParaRPr lang="fr-FR" dirty="0" smtClean="0"/>
           </a:p>
           <a:p>
             <a:endParaRPr lang="fr-FR" dirty="0"/>
@@ -13159,39 +13604,193 @@
             </a:pPr>
             <a:r>
               <a:rPr lang="fr-FR" dirty="0" smtClean="0"/>
-              <a:t>Dans ce TP, Azure met à disposition une méthode : </a:t>
+              <a:t>In </a:t>
+            </a:r>
+            <a:r>
+              <a:rPr lang="fr-FR" dirty="0" err="1" smtClean="0"/>
+              <a:t>this</a:t>
+            </a:r>
+            <a:r>
+              <a:rPr lang="fr-FR" dirty="0" smtClean="0"/>
+              <a:t> </a:t>
+            </a:r>
+            <a:r>
+              <a:rPr lang="fr-FR" dirty="0" err="1" smtClean="0"/>
+              <a:t>lab</a:t>
+            </a:r>
+            <a:r>
+              <a:rPr lang="fr-FR" dirty="0" smtClean="0"/>
+              <a:t>, Azure </a:t>
+            </a:r>
+            <a:r>
+              <a:rPr lang="fr-FR" dirty="0" err="1" smtClean="0"/>
+              <a:t>provides</a:t>
+            </a:r>
+            <a:r>
+              <a:rPr lang="fr-FR" dirty="0" smtClean="0"/>
+              <a:t> us </a:t>
+            </a:r>
+            <a:r>
+              <a:rPr lang="fr-FR" dirty="0" err="1" smtClean="0"/>
+              <a:t>with</a:t>
+            </a:r>
+            <a:r>
+              <a:rPr lang="fr-FR" dirty="0" smtClean="0"/>
+              <a:t> one </a:t>
+            </a:r>
+            <a:r>
+              <a:rPr lang="fr-FR" dirty="0" err="1" smtClean="0"/>
+              <a:t>method</a:t>
+            </a:r>
+            <a:r>
+              <a:rPr lang="fr-FR" dirty="0" smtClean="0"/>
+              <a:t> </a:t>
+            </a:r>
+            <a:r>
+              <a:rPr lang="fr-FR" dirty="0" smtClean="0"/>
+              <a:t>: </a:t>
             </a:r>
             <a:r>
               <a:rPr lang="fr-FR" b="1" dirty="0" err="1" smtClean="0"/>
               <a:t>sweep</a:t>
             </a:r>
             <a:r>
+              <a:rPr lang="fr-FR" b="1" dirty="0" smtClean="0"/>
+              <a:t>()</a:t>
+            </a:r>
+            <a:r>
               <a:rPr lang="fr-FR" dirty="0" smtClean="0"/>
               <a:t> </a:t>
             </a:r>
-          </a:p>
-          <a:p>
+            <a:endParaRPr lang="fr-FR" dirty="0" smtClean="0"/>
+          </a:p>
+          <a:p>
+            <a:r>
+              <a:rPr lang="fr-FR" dirty="0" err="1" smtClean="0"/>
+              <a:t>Define</a:t>
+            </a:r>
             <a:r>
               <a:rPr lang="fr-FR" dirty="0" smtClean="0"/>
-              <a:t>Il faut choisir plusieurs valeurs possibles pour nos paramètres</a:t>
-            </a:r>
-          </a:p>
-          <a:p>
+              <a:t> a </a:t>
+            </a:r>
+            <a:r>
+              <a:rPr lang="fr-FR" dirty="0" err="1" smtClean="0"/>
+              <a:t>search</a:t>
+            </a:r>
             <a:r>
               <a:rPr lang="fr-FR" dirty="0" smtClean="0"/>
-              <a:t>Cette méthode va tester toutes ou certaines combinaisons de paramètres et trouver l’entraînement qui va produire le meilleur modèle final</a:t>
-            </a:r>
-          </a:p>
-          <a:p>
+              <a:t> </a:t>
+            </a:r>
+            <a:r>
+              <a:rPr lang="fr-FR" dirty="0" err="1" smtClean="0"/>
+              <a:t>space</a:t>
+            </a:r>
             <a:r>
               <a:rPr lang="fr-FR" dirty="0" smtClean="0"/>
-              <a:t> Il faut choisir aussi un seuil de tolérance qui permet d’arrêter l’entrainement si on s’aperçoit que le modèle ne sera pas bon</a:t>
-            </a:r>
-          </a:p>
-          <a:p>
-            <a:pPr marL="0" indent="0">
-              <a:buNone/>
-            </a:pPr>
+              <a:t> : </a:t>
+            </a:r>
+            <a:r>
+              <a:rPr lang="fr-FR" dirty="0" err="1" smtClean="0"/>
+              <a:t>give</a:t>
+            </a:r>
+            <a:r>
+              <a:rPr lang="fr-FR" dirty="0" smtClean="0"/>
+              <a:t> ranges of values for </a:t>
+            </a:r>
+            <a:r>
+              <a:rPr lang="fr-FR" dirty="0" err="1" smtClean="0"/>
+              <a:t>each</a:t>
+            </a:r>
+            <a:r>
+              <a:rPr lang="fr-FR" dirty="0" smtClean="0"/>
+              <a:t> </a:t>
+            </a:r>
+            <a:r>
+              <a:rPr lang="fr-FR" dirty="0" err="1" smtClean="0"/>
+              <a:t>hyperparameter</a:t>
+            </a:r>
+            <a:r>
+              <a:rPr lang="fr-FR" dirty="0" smtClean="0"/>
+              <a:t> </a:t>
+            </a:r>
+            <a:r>
+              <a:rPr lang="fr-FR" dirty="0" err="1" smtClean="0"/>
+              <a:t>you</a:t>
+            </a:r>
+            <a:r>
+              <a:rPr lang="fr-FR" dirty="0" smtClean="0"/>
+              <a:t> </a:t>
+            </a:r>
+            <a:r>
+              <a:rPr lang="fr-FR" dirty="0" err="1" smtClean="0"/>
+              <a:t>want</a:t>
+            </a:r>
+            <a:r>
+              <a:rPr lang="fr-FR" dirty="0" smtClean="0"/>
+              <a:t> to tune</a:t>
+            </a:r>
+            <a:endParaRPr lang="fr-FR" dirty="0" smtClean="0"/>
+          </a:p>
+          <a:p>
+            <a:r>
+              <a:rPr lang="fr-FR" b="1" dirty="0" err="1"/>
+              <a:t>s</a:t>
+            </a:r>
+            <a:r>
+              <a:rPr lang="fr-FR" b="1" dirty="0" err="1" smtClean="0"/>
+              <a:t>weep</a:t>
+            </a:r>
+            <a:r>
+              <a:rPr lang="fr-FR" b="1" dirty="0" smtClean="0"/>
+              <a:t>() </a:t>
+            </a:r>
+            <a:r>
+              <a:rPr lang="fr-FR" dirty="0" err="1" smtClean="0"/>
+              <a:t>will</a:t>
+            </a:r>
+            <a:r>
+              <a:rPr lang="fr-FR" dirty="0" smtClean="0"/>
+              <a:t> test all or </a:t>
+            </a:r>
+            <a:r>
+              <a:rPr lang="fr-FR" dirty="0" err="1" smtClean="0"/>
+              <a:t>some</a:t>
+            </a:r>
+            <a:r>
+              <a:rPr lang="fr-FR" dirty="0" smtClean="0"/>
+              <a:t> </a:t>
+            </a:r>
+            <a:r>
+              <a:rPr lang="fr-FR" dirty="0" err="1" smtClean="0"/>
+              <a:t>combinations</a:t>
+            </a:r>
+            <a:r>
+              <a:rPr lang="fr-FR" dirty="0" smtClean="0"/>
+              <a:t> of </a:t>
+            </a:r>
+            <a:r>
+              <a:rPr lang="fr-FR" dirty="0" err="1" smtClean="0"/>
+              <a:t>hyperparameters</a:t>
+            </a:r>
+            <a:r>
+              <a:rPr lang="fr-FR" dirty="0" smtClean="0"/>
+              <a:t> and output the best </a:t>
+            </a:r>
+            <a:r>
+              <a:rPr lang="fr-FR" dirty="0" err="1" smtClean="0"/>
+              <a:t>result</a:t>
+            </a:r>
+            <a:endParaRPr lang="fr-FR" dirty="0" smtClean="0"/>
+          </a:p>
+          <a:p>
+            <a:r>
+              <a:rPr lang="en-US" dirty="0"/>
+              <a:t>You also need to choose a tolerance threshold that allows you to stop training if it becomes clear that the model will not perform </a:t>
+            </a:r>
+            <a:r>
+              <a:rPr lang="en-US" dirty="0" smtClean="0"/>
+              <a:t>well</a:t>
+            </a:r>
             <a:endParaRPr lang="fr-FR" dirty="0"/>
           </a:p>
         </p:txBody>
@@ -13243,7 +13842,11 @@
           <a:p>
             <a:r>
               <a:rPr lang="fr-FR" dirty="0" smtClean="0"/>
-              <a:t>Déploiement du modèle</a:t>
+              <a:t>Model </a:t>
+            </a:r>
+            <a:r>
+              <a:rPr lang="fr-FR" dirty="0" err="1" smtClean="0"/>
+              <a:t>deployment</a:t>
             </a:r>
             <a:endParaRPr lang="fr-FR" dirty="0"/>
           </a:p>
@@ -13259,14 +13862,31 @@
             <p:ph type="body" sz="quarter" idx="10"/>
           </p:nvPr>
         </p:nvSpPr>
-        <p:spPr/>
+        <p:spPr>
+          <a:xfrm>
+            <a:off x="4385569" y="4459399"/>
+            <a:ext cx="7222956" cy="1128170"/>
+          </a:xfrm>
+        </p:spPr>
         <p:txBody>
           <a:bodyPr/>
           <a:lstStyle/>
           <a:p>
             <a:r>
-              <a:rPr lang="fr-FR" dirty="0" smtClean="0"/>
-              <a:t>Fonctionnement, inférence en temps réel et en lot</a:t>
+              <a:rPr lang="en-US" dirty="0" smtClean="0"/>
+              <a:t>Specificities, </a:t>
+            </a:r>
+            <a:r>
+              <a:rPr lang="en-US" dirty="0"/>
+              <a:t>Batch inference </a:t>
+            </a:r>
+            <a:r>
+              <a:rPr lang="en-US" dirty="0" smtClean="0"/>
+              <a:t>V.S. </a:t>
+            </a:r>
+            <a:r>
+              <a:rPr lang="en-US" dirty="0"/>
+              <a:t>streaming</a:t>
             </a:r>
             <a:endParaRPr lang="fr-FR" dirty="0"/>
           </a:p>
@@ -13318,12 +13938,16 @@
           <a:lstStyle/>
           <a:p>
             <a:r>
-              <a:rPr lang="fr-FR" dirty="0" err="1" smtClean="0"/>
+              <a:rPr lang="fr-FR" dirty="0" err="1"/>
               <a:t>Endpoints</a:t>
             </a:r>
             <a:r>
-              <a:rPr lang="fr-FR" dirty="0" smtClean="0"/>
-              <a:t> et déploiements</a:t>
+              <a:rPr lang="fr-FR" dirty="0"/>
+              <a:t> &amp; </a:t>
+            </a:r>
+            <a:r>
+              <a:rPr lang="fr-FR" dirty="0" err="1"/>
+              <a:t>Deployments</a:t>
             </a:r>
             <a:endParaRPr lang="fr-FR" dirty="0"/>
           </a:p>
@@ -13360,29 +13984,6 @@
       </p:sp>
       <p:sp>
         <p:nvSpPr>
-          <p:cNvPr id="5" name="Espace réservé du pied de page 4"/>
-          <p:cNvSpPr>
-            <a:spLocks noGrp="1"/>
-          </p:cNvSpPr>
-          <p:nvPr>
-            <p:ph type="ftr" sz="quarter" idx="3"/>
-          </p:nvPr>
-        </p:nvSpPr>
-        <p:spPr/>
-        <p:txBody>
-          <a:bodyPr/>
-          <a:lstStyle/>
-          <a:p>
-            <a:r>
-              <a:rPr lang="en-US" smtClean="0"/>
-              <a:t>2024 | ©HeadMind Partners</a:t>
-            </a:r>
-            <a:endParaRPr lang="fr-FR" dirty="0"/>
-          </a:p>
-        </p:txBody>
-      </p:sp>
-      <p:sp>
-        <p:nvSpPr>
           <p:cNvPr id="6" name="Espace réservé du texte 5"/>
           <p:cNvSpPr>
             <a:spLocks noGrp="1"/>
@@ -13410,138 +14011,97 @@
             </a:r>
             <a:r>
               <a:rPr lang="fr-FR" dirty="0" smtClean="0"/>
-              <a:t> ? (Point de terminaison)</a:t>
-            </a:r>
-          </a:p>
-          <a:p>
-            <a:pPr algn="just"/>
-            <a:r>
-              <a:rPr lang="fr-FR" dirty="0"/>
-              <a:t>L'</a:t>
-            </a:r>
-            <a:r>
-              <a:rPr lang="fr-FR" dirty="0" err="1"/>
-              <a:t>endpoint</a:t>
-            </a:r>
-            <a:r>
-              <a:rPr lang="fr-FR" dirty="0"/>
-              <a:t> est un </a:t>
-            </a:r>
-            <a:r>
-              <a:rPr lang="fr-FR" dirty="0" smtClean="0"/>
-              <a:t>serveur.</a:t>
-            </a:r>
-            <a:r>
-              <a:rPr lang="fr-FR" dirty="0"/>
-              <a:t> Il gère les requêtes qu'il </a:t>
-            </a:r>
-            <a:r>
-              <a:rPr lang="fr-FR" dirty="0" smtClean="0"/>
-              <a:t>reçoit</a:t>
-            </a:r>
-            <a:r>
-              <a:rPr lang="fr-FR" dirty="0"/>
-              <a:t> distribue les calculs pour </a:t>
-            </a:r>
-            <a:r>
-              <a:rPr lang="fr-FR" dirty="0" smtClean="0"/>
-              <a:t>une    réponse</a:t>
-            </a:r>
-            <a:r>
-              <a:rPr lang="fr-FR" dirty="0"/>
-              <a:t> avec un </a:t>
-            </a:r>
-            <a:r>
-              <a:rPr lang="fr-FR" dirty="0" smtClean="0"/>
-              <a:t> minimum</a:t>
-            </a:r>
-            <a:r>
-              <a:rPr lang="fr-FR" dirty="0"/>
-              <a:t> de latence. On expose donc un modèle via une API, permettant aux </a:t>
-            </a:r>
-            <a:r>
-              <a:rPr lang="fr-FR" dirty="0" smtClean="0"/>
-              <a:t>applications d'envoyer</a:t>
-            </a:r>
-            <a:r>
-              <a:rPr lang="fr-FR" dirty="0"/>
-              <a:t> des données et de recevoir des prédictions.</a:t>
-            </a:r>
+              <a:t> ? </a:t>
+            </a:r>
+            <a:endParaRPr lang="fr-FR" dirty="0" smtClean="0"/>
+          </a:p>
+          <a:p>
+            <a:r>
+              <a:rPr lang="en-US" dirty="0"/>
+              <a:t>An endpoint is a server that handles incoming requests. It distributes the necessary computations to provide responses with minimal latency. </a:t>
+            </a:r>
+            <a:endParaRPr lang="en-US" dirty="0" smtClean="0"/>
+          </a:p>
+          <a:p>
+            <a:r>
+              <a:rPr lang="en-US" dirty="0" smtClean="0"/>
+              <a:t>By </a:t>
+            </a:r>
+            <a:r>
+              <a:rPr lang="en-US" dirty="0"/>
+              <a:t>exposing a model through an API, applications can send data and receive predictions</a:t>
+            </a:r>
+            <a:r>
+              <a:rPr lang="en-US" dirty="0" smtClean="0"/>
+              <a:t>.</a:t>
+            </a:r>
+          </a:p>
+          <a:p>
+            <a:endParaRPr lang="fr-FR" dirty="0"/>
           </a:p>
           <a:p>
             <a:pPr marL="0" indent="0">
               <a:buNone/>
             </a:pPr>
-            <a:endParaRPr lang="fr-FR" dirty="0"/>
+            <a:r>
+              <a:rPr lang="en-US" b="1" dirty="0" smtClean="0"/>
+              <a:t>Deploying</a:t>
+            </a:r>
+            <a:r>
+              <a:rPr lang="en-US" dirty="0" smtClean="0"/>
+              <a:t> </a:t>
+            </a:r>
+            <a:r>
+              <a:rPr lang="en-US" dirty="0"/>
+              <a:t>to an endpoint involves allocating a resource that hosts a model and makes it accessible via an API for inference.</a:t>
+            </a:r>
           </a:p>
           <a:p>
             <a:pPr marL="0" indent="0">
               <a:buNone/>
             </a:pPr>
-            <a:r>
-              <a:rPr lang="fr-FR" dirty="0"/>
-              <a:t>Un </a:t>
-            </a:r>
-            <a:r>
-              <a:rPr lang="fr-FR" b="1" dirty="0"/>
-              <a:t>déploiement</a:t>
-            </a:r>
-            <a:r>
-              <a:rPr lang="fr-FR" dirty="0"/>
-              <a:t> sur un </a:t>
-            </a:r>
-            <a:r>
-              <a:rPr lang="fr-FR" dirty="0" err="1"/>
-              <a:t>endpoint</a:t>
-            </a:r>
-            <a:r>
-              <a:rPr lang="fr-FR" dirty="0"/>
-              <a:t> </a:t>
-            </a:r>
-            <a:r>
-              <a:rPr lang="fr-FR" dirty="0" smtClean="0"/>
-              <a:t>est</a:t>
-            </a:r>
-            <a:r>
-              <a:rPr lang="fr-FR" dirty="0"/>
-              <a:t> l'allocation d'une </a:t>
-            </a:r>
-            <a:r>
-              <a:rPr lang="fr-FR" dirty="0" smtClean="0"/>
-              <a:t>ressource</a:t>
-            </a:r>
-            <a:r>
-              <a:rPr lang="fr-FR" dirty="0"/>
-              <a:t> </a:t>
-            </a:r>
-            <a:r>
-              <a:rPr lang="fr-FR" dirty="0" smtClean="0"/>
-              <a:t>hébergeant</a:t>
-            </a:r>
-            <a:r>
-              <a:rPr lang="fr-FR" dirty="0"/>
-              <a:t> </a:t>
-            </a:r>
-            <a:r>
-              <a:rPr lang="fr-FR" dirty="0" smtClean="0"/>
-              <a:t>un</a:t>
-            </a:r>
-            <a:r>
-              <a:rPr lang="fr-FR" dirty="0"/>
-              <a:t> modèle et le rend accessible </a:t>
-            </a:r>
-            <a:r>
-              <a:rPr lang="fr-FR" dirty="0" smtClean="0"/>
-              <a:t>via une</a:t>
-            </a:r>
-            <a:r>
-              <a:rPr lang="fr-FR" dirty="0"/>
-              <a:t> API pour inférence</a:t>
-            </a:r>
-            <a:r>
-              <a:rPr lang="fr-FR" dirty="0" smtClean="0"/>
-              <a:t>.</a:t>
-            </a:r>
+            <a:endParaRPr lang="en-US" dirty="0"/>
+          </a:p>
+          <a:p>
+            <a:pPr marL="0" indent="0">
+              <a:buNone/>
+            </a:pPr>
+            <a:endParaRPr lang="en-US" dirty="0"/>
+          </a:p>
+          <a:p>
+            <a:pPr marL="0" indent="0">
+              <a:buNone/>
+            </a:pPr>
+            <a:endParaRPr lang="en-US" dirty="0"/>
+          </a:p>
+          <a:p>
+            <a:pPr marL="0" indent="0">
+              <a:buNone/>
+            </a:pPr>
+            <a:endParaRPr lang="en-US" dirty="0"/>
+          </a:p>
+          <a:p>
+            <a:pPr marL="0" indent="0">
+              <a:buNone/>
+            </a:pPr>
+            <a:endParaRPr lang="en-US" dirty="0"/>
+          </a:p>
+          <a:p>
+            <a:pPr marL="0" indent="0">
+              <a:buNone/>
+            </a:pPr>
+            <a:endParaRPr lang="en-US" dirty="0"/>
+          </a:p>
+          <a:p>
+            <a:pPr marL="0" indent="0">
+              <a:buNone/>
+            </a:pPr>
+            <a:endParaRPr lang="fr-FR" dirty="0" smtClean="0"/>
+          </a:p>
+          <a:p>
+            <a:pPr marL="0" indent="0">
+              <a:buNone/>
+            </a:pPr>
             <a:endParaRPr lang="fr-FR" dirty="0"/>
           </a:p>
           <a:p>
@@ -13568,14 +14128,54 @@
         </p:blipFill>
         <p:spPr>
           <a:xfrm>
-            <a:off x="3800476" y="4206987"/>
-            <a:ext cx="4378692" cy="1828688"/>
+            <a:off x="2956264" y="4077512"/>
+            <a:ext cx="4909537" cy="2050387"/>
           </a:xfrm>
           <a:prstGeom prst="rect">
             <a:avLst/>
           </a:prstGeom>
         </p:spPr>
       </p:pic>
+      <p:sp>
+        <p:nvSpPr>
+          <p:cNvPr id="7" name="Espace réservé du pied de page 4"/>
+          <p:cNvSpPr>
+            <a:spLocks noGrp="1"/>
+          </p:cNvSpPr>
+          <p:nvPr>
+            <p:ph type="ftr" sz="quarter" idx="3"/>
+          </p:nvPr>
+        </p:nvSpPr>
+        <p:spPr>
+          <a:xfrm>
+            <a:off x="194408" y="6435303"/>
+            <a:ext cx="5672016" cy="365125"/>
+          </a:xfrm>
+        </p:spPr>
+        <p:txBody>
+          <a:bodyPr/>
+          <a:lstStyle/>
+          <a:p>
+            <a:r>
+              <a:rPr lang="en-US" dirty="0" smtClean="0"/>
+              <a:t>2025 </a:t>
+            </a:r>
+            <a:r>
+              <a:rPr lang="en-US" dirty="0" smtClean="0"/>
+              <a:t>| ©</a:t>
+            </a:r>
+            <a:r>
+              <a:rPr lang="en-US" dirty="0" err="1" smtClean="0"/>
+              <a:t>HeadMind</a:t>
+            </a:r>
+            <a:r>
+              <a:rPr lang="en-US" dirty="0" smtClean="0"/>
+              <a:t> Partners</a:t>
+            </a:r>
+            <a:endParaRPr lang="fr-FR" dirty="0"/>
+          </a:p>
+        </p:txBody>
+      </p:sp>
     </p:spTree>
     <p:extLst>
       <p:ext uri="{BB962C8B-B14F-4D97-AF65-F5344CB8AC3E}">
@@ -13586,6 +14186,13 @@
   <p:clrMapOvr>
     <a:masterClrMapping/>
   </p:clrMapOvr>
+  <p:timing>
+    <p:tnLst>
+      <p:par>
+        <p:cTn id="1" dur="indefinite" restart="never" nodeType="tmRoot"/>
+      </p:par>
+    </p:tnLst>
+  </p:timing>
 </p:sld>
 </file>
 
@@ -13660,241 +14267,464 @@
       </p:sp>
       <p:sp>
         <p:nvSpPr>
-          <p:cNvPr id="4" name="Espace réservé du pied de page 3"/>
-          <p:cNvSpPr>
-            <a:spLocks noGrp="1"/>
-          </p:cNvSpPr>
-          <p:nvPr>
-            <p:ph type="ftr" sz="quarter" idx="3"/>
-          </p:nvPr>
-        </p:nvSpPr>
-        <p:spPr/>
+          <p:cNvPr id="5" name="Espace réservé du texte 4"/>
+          <p:cNvSpPr>
+            <a:spLocks noGrp="1"/>
+          </p:cNvSpPr>
+          <p:nvPr>
+            <p:ph type="body" sz="quarter" idx="13"/>
+          </p:nvPr>
+        </p:nvSpPr>
+        <p:spPr>
+          <a:xfrm>
+            <a:off x="818228" y="2845802"/>
+            <a:ext cx="4557487" cy="3132088"/>
+          </a:xfrm>
+        </p:spPr>
         <p:txBody>
           <a:bodyPr/>
           <a:lstStyle/>
           <a:p>
             <a:r>
-              <a:rPr lang="en-US" smtClean="0"/>
-              <a:t>2024 | ©HeadMind Partners</a:t>
-            </a:r>
+              <a:rPr lang="fr-FR" dirty="0" err="1"/>
+              <a:t>Idea</a:t>
+            </a:r>
+            <a:r>
+              <a:rPr lang="fr-FR" dirty="0"/>
+              <a:t>: </a:t>
+            </a:r>
+            <a:r>
+              <a:rPr lang="fr-FR" dirty="0" err="1"/>
+              <a:t>Process</a:t>
+            </a:r>
+            <a:r>
+              <a:rPr lang="fr-FR" dirty="0"/>
+              <a:t> large volumes of data by </a:t>
+            </a:r>
+            <a:r>
+              <a:rPr lang="fr-FR" dirty="0" err="1"/>
+              <a:t>parallelizing</a:t>
+            </a:r>
+            <a:r>
+              <a:rPr lang="fr-FR" dirty="0"/>
+              <a:t> computations, </a:t>
+            </a:r>
+            <a:r>
+              <a:rPr lang="fr-FR" dirty="0" err="1"/>
+              <a:t>particularly</a:t>
+            </a:r>
+            <a:r>
+              <a:rPr lang="fr-FR" dirty="0"/>
+              <a:t> </a:t>
+            </a:r>
+            <a:r>
+              <a:rPr lang="fr-FR" dirty="0" err="1"/>
+              <a:t>using</a:t>
+            </a:r>
+            <a:r>
+              <a:rPr lang="fr-FR" dirty="0"/>
+              <a:t> </a:t>
+            </a:r>
+            <a:r>
+              <a:rPr lang="fr-FR" dirty="0" err="1"/>
+              <a:t>GPUs</a:t>
+            </a:r>
+            <a:r>
+              <a:rPr lang="fr-FR" dirty="0"/>
+              <a:t>.</a:t>
+            </a:r>
+          </a:p>
+          <a:p>
+            <a:pPr marL="285750" indent="-285750">
+              <a:buFont typeface="Arial" panose="020B0604020202020204" pitchFamily="34" charset="0"/>
+              <a:buChar char="•"/>
+            </a:pPr>
+            <a:r>
+              <a:rPr lang="fr-FR" dirty="0" err="1"/>
+              <a:t>Accelerates</a:t>
+            </a:r>
+            <a:r>
+              <a:rPr lang="fr-FR" dirty="0"/>
+              <a:t> data </a:t>
+            </a:r>
+            <a:r>
+              <a:rPr lang="fr-FR" dirty="0" err="1"/>
+              <a:t>processing</a:t>
+            </a:r>
+            <a:r>
+              <a:rPr lang="fr-FR" dirty="0"/>
+              <a:t> and </a:t>
+            </a:r>
+            <a:r>
+              <a:rPr lang="fr-FR" dirty="0" err="1"/>
+              <a:t>optimizes</a:t>
+            </a:r>
+            <a:r>
+              <a:rPr lang="fr-FR" dirty="0"/>
+              <a:t> </a:t>
+            </a:r>
+            <a:r>
+              <a:rPr lang="fr-FR" dirty="0" err="1"/>
+              <a:t>compute</a:t>
+            </a:r>
+            <a:r>
+              <a:rPr lang="fr-FR" dirty="0"/>
+              <a:t> </a:t>
+            </a:r>
+            <a:r>
+              <a:rPr lang="fr-FR" dirty="0" err="1"/>
+              <a:t>resource</a:t>
+            </a:r>
+            <a:r>
+              <a:rPr lang="fr-FR" dirty="0"/>
+              <a:t> </a:t>
+            </a:r>
+            <a:r>
+              <a:rPr lang="fr-FR" dirty="0" err="1"/>
+              <a:t>utilization</a:t>
+            </a:r>
+            <a:r>
+              <a:rPr lang="fr-FR" dirty="0"/>
+              <a:t>, </a:t>
+            </a:r>
+            <a:r>
+              <a:rPr lang="fr-FR" dirty="0" err="1"/>
+              <a:t>thereby</a:t>
+            </a:r>
+            <a:r>
+              <a:rPr lang="fr-FR" dirty="0"/>
+              <a:t> </a:t>
+            </a:r>
+            <a:r>
+              <a:rPr lang="fr-FR" dirty="0" err="1"/>
+              <a:t>reducing</a:t>
+            </a:r>
+            <a:r>
+              <a:rPr lang="fr-FR" dirty="0"/>
+              <a:t> </a:t>
+            </a:r>
+            <a:r>
+              <a:rPr lang="fr-FR" dirty="0" err="1"/>
+              <a:t>operational</a:t>
+            </a:r>
+            <a:r>
+              <a:rPr lang="fr-FR" dirty="0"/>
+              <a:t> </a:t>
+            </a:r>
+            <a:r>
+              <a:rPr lang="fr-FR" dirty="0" err="1"/>
+              <a:t>costs</a:t>
+            </a:r>
+            <a:r>
+              <a:rPr lang="fr-FR" dirty="0"/>
+              <a:t>.</a:t>
+            </a:r>
+          </a:p>
+          <a:p>
+            <a:pPr marL="285750" indent="-285750">
+              <a:buFont typeface="Arial" panose="020B0604020202020204" pitchFamily="34" charset="0"/>
+              <a:buChar char="•"/>
+            </a:pPr>
+            <a:r>
+              <a:rPr lang="fr-FR" dirty="0"/>
+              <a:t>May </a:t>
+            </a:r>
+            <a:r>
+              <a:rPr lang="fr-FR" dirty="0" err="1"/>
+              <a:t>introduce</a:t>
+            </a:r>
+            <a:r>
+              <a:rPr lang="fr-FR" dirty="0"/>
+              <a:t> </a:t>
+            </a:r>
+            <a:r>
+              <a:rPr lang="fr-FR" dirty="0" err="1"/>
+              <a:t>inference</a:t>
+            </a:r>
+            <a:r>
+              <a:rPr lang="fr-FR" dirty="0"/>
+              <a:t> </a:t>
+            </a:r>
+            <a:r>
+              <a:rPr lang="fr-FR" dirty="0" err="1" smtClean="0"/>
+              <a:t>latencies</a:t>
+            </a:r>
+            <a:r>
+              <a:rPr lang="fr-FR" dirty="0"/>
+              <a:t> </a:t>
+            </a:r>
+            <a:r>
+              <a:rPr lang="fr-FR" dirty="0" smtClean="0"/>
+              <a:t>(</a:t>
+            </a:r>
+            <a:r>
+              <a:rPr lang="fr-FR" dirty="0" err="1" smtClean="0"/>
+              <a:t>wait</a:t>
+            </a:r>
+            <a:r>
+              <a:rPr lang="fr-FR" dirty="0" smtClean="0"/>
+              <a:t> for the batch to </a:t>
+            </a:r>
+            <a:r>
+              <a:rPr lang="fr-FR" dirty="0" err="1" smtClean="0"/>
+              <a:t>be</a:t>
+            </a:r>
+            <a:r>
+              <a:rPr lang="fr-FR" dirty="0" smtClean="0"/>
+              <a:t> </a:t>
+            </a:r>
+            <a:r>
+              <a:rPr lang="fr-FR" dirty="0" err="1" smtClean="0"/>
+              <a:t>filled</a:t>
+            </a:r>
+            <a:r>
+              <a:rPr lang="fr-FR" dirty="0" smtClean="0"/>
+              <a:t>, </a:t>
+            </a:r>
+            <a:r>
+              <a:rPr lang="fr-FR" dirty="0" err="1" smtClean="0"/>
+              <a:t>then</a:t>
+            </a:r>
+            <a:r>
+              <a:rPr lang="fr-FR" dirty="0" smtClean="0"/>
+              <a:t> </a:t>
+            </a:r>
+            <a:r>
+              <a:rPr lang="fr-FR" dirty="0" err="1" smtClean="0"/>
+              <a:t>you</a:t>
+            </a:r>
+            <a:r>
+              <a:rPr lang="fr-FR" dirty="0" smtClean="0"/>
+              <a:t> </a:t>
+            </a:r>
+            <a:r>
+              <a:rPr lang="fr-FR" dirty="0" err="1" smtClean="0"/>
+              <a:t>can</a:t>
+            </a:r>
+            <a:r>
+              <a:rPr lang="fr-FR" dirty="0" smtClean="0"/>
+              <a:t> </a:t>
+            </a:r>
+            <a:r>
+              <a:rPr lang="fr-FR" dirty="0" err="1" smtClean="0"/>
+              <a:t>start</a:t>
+            </a:r>
+            <a:r>
+              <a:rPr lang="fr-FR" dirty="0" smtClean="0"/>
+              <a:t> </a:t>
+            </a:r>
+            <a:r>
+              <a:rPr lang="fr-FR" dirty="0" err="1" smtClean="0"/>
+              <a:t>processing</a:t>
+            </a:r>
+            <a:r>
+              <a:rPr lang="fr-FR" dirty="0" smtClean="0"/>
+              <a:t>)</a:t>
+            </a:r>
+          </a:p>
+          <a:p>
+            <a:pPr marL="285750" indent="-285750">
+              <a:buFont typeface="Arial" panose="020B0604020202020204" pitchFamily="34" charset="0"/>
+              <a:buChar char="•"/>
+            </a:pPr>
             <a:endParaRPr lang="fr-FR" dirty="0"/>
           </a:p>
-        </p:txBody>
-      </p:sp>
-      <p:sp>
-        <p:nvSpPr>
-          <p:cNvPr id="5" name="Espace réservé du texte 4"/>
-          <p:cNvSpPr>
-            <a:spLocks noGrp="1"/>
-          </p:cNvSpPr>
-          <p:nvPr>
-            <p:ph type="body" sz="quarter" idx="13"/>
-          </p:nvPr>
-        </p:nvSpPr>
-        <p:spPr>
-          <a:xfrm>
-            <a:off x="818228" y="2845802"/>
-            <a:ext cx="4557487" cy="3132088"/>
-          </a:xfrm>
-        </p:spPr>
+          <a:p>
+            <a:r>
+              <a:rPr lang="fr-FR" dirty="0" err="1" smtClean="0"/>
+              <a:t>Examples</a:t>
+            </a:r>
+            <a:r>
+              <a:rPr lang="fr-FR" dirty="0" smtClean="0"/>
+              <a:t> :</a:t>
+            </a:r>
+            <a:endParaRPr lang="fr-FR" dirty="0"/>
+          </a:p>
+          <a:p>
+            <a:r>
+              <a:rPr lang="fr-FR" dirty="0"/>
+              <a:t>Image </a:t>
+            </a:r>
+            <a:r>
+              <a:rPr lang="fr-FR" dirty="0" smtClean="0"/>
+              <a:t>classification, </a:t>
+            </a:r>
+            <a:r>
+              <a:rPr lang="fr-FR" dirty="0" err="1" smtClean="0"/>
+              <a:t>Hyperparameter</a:t>
+            </a:r>
+            <a:r>
+              <a:rPr lang="fr-FR" dirty="0" smtClean="0"/>
+              <a:t> </a:t>
+            </a:r>
+            <a:r>
+              <a:rPr lang="fr-FR" dirty="0" err="1" smtClean="0"/>
+              <a:t>tuning</a:t>
+            </a:r>
+            <a:r>
+              <a:rPr lang="fr-FR" dirty="0" smtClean="0"/>
+              <a:t>, Large workflow </a:t>
+            </a:r>
+            <a:r>
+              <a:rPr lang="fr-FR" dirty="0" err="1" smtClean="0"/>
+              <a:t>scheduled</a:t>
+            </a:r>
+            <a:r>
+              <a:rPr lang="fr-FR" dirty="0" smtClean="0"/>
+              <a:t> </a:t>
+            </a:r>
+            <a:r>
+              <a:rPr lang="fr-FR" dirty="0" err="1" smtClean="0"/>
+              <a:t>every</a:t>
+            </a:r>
+            <a:r>
+              <a:rPr lang="fr-FR" dirty="0" smtClean="0"/>
+              <a:t> night</a:t>
+            </a:r>
+          </a:p>
+        </p:txBody>
+      </p:sp>
+      <p:sp>
+        <p:nvSpPr>
+          <p:cNvPr id="6" name="Espace réservé du texte 5"/>
+          <p:cNvSpPr>
+            <a:spLocks noGrp="1"/>
+          </p:cNvSpPr>
+          <p:nvPr>
+            <p:ph type="body" sz="quarter" idx="18"/>
+          </p:nvPr>
+        </p:nvSpPr>
+        <p:spPr/>
         <p:txBody>
           <a:bodyPr/>
           <a:lstStyle/>
           <a:p>
             <a:r>
-              <a:rPr lang="fr-FR" dirty="0"/>
-              <a:t>Idée : traiter de grande quantité de données en parallélisant les calculs notamment à l’aide de GPU</a:t>
-            </a:r>
-            <a:r>
               <a:rPr lang="fr-FR" dirty="0" smtClean="0"/>
-              <a:t>.</a:t>
-            </a:r>
-          </a:p>
-          <a:p>
+              <a:t>Batch </a:t>
+            </a:r>
+            <a:r>
+              <a:rPr lang="fr-FR" dirty="0" err="1" smtClean="0"/>
+              <a:t>inference</a:t>
+            </a:r>
             <a:endParaRPr lang="fr-FR" dirty="0"/>
           </a:p>
-          <a:p>
-            <a:pPr marL="285750" indent="-285750">
-              <a:buFontTx/>
-              <a:buChar char="-"/>
-            </a:pPr>
-            <a:r>
-              <a:rPr lang="fr-FR" dirty="0"/>
-              <a:t>Accélère le traitement de données et optimise l’utilisation des ressources de calculs ce qui réduit les coûts </a:t>
-            </a:r>
-            <a:r>
-              <a:rPr lang="fr-FR" dirty="0" smtClean="0"/>
-              <a:t>d’utilisation</a:t>
-            </a:r>
-          </a:p>
-          <a:p>
-            <a:pPr marL="285750" indent="-285750">
-              <a:buFontTx/>
-              <a:buChar char="-"/>
-            </a:pPr>
-            <a:r>
-              <a:rPr lang="fr-FR" dirty="0" smtClean="0"/>
-              <a:t>Entraine des latences à l’inférence.</a:t>
-            </a:r>
-          </a:p>
-          <a:p>
-            <a:pPr marL="285750" indent="-285750">
-              <a:buFontTx/>
-              <a:buChar char="-"/>
-            </a:pPr>
-            <a:endParaRPr lang="fr-FR" dirty="0" smtClean="0"/>
-          </a:p>
-          <a:p>
-            <a:r>
-              <a:rPr lang="fr-FR" dirty="0" smtClean="0"/>
-              <a:t>Exemple : </a:t>
-            </a:r>
-          </a:p>
-          <a:p>
-            <a:r>
-              <a:rPr lang="fr-FR" dirty="0" smtClean="0"/>
-              <a:t>Classification d’images, réglage d’</a:t>
-            </a:r>
-            <a:r>
-              <a:rPr lang="fr-FR" dirty="0" err="1" smtClean="0"/>
-              <a:t>hyperparamètres</a:t>
-            </a:r>
-            <a:endParaRPr lang="fr-FR" dirty="0"/>
-          </a:p>
-        </p:txBody>
-      </p:sp>
-      <p:sp>
-        <p:nvSpPr>
-          <p:cNvPr id="6" name="Espace réservé du texte 5"/>
-          <p:cNvSpPr>
-            <a:spLocks noGrp="1"/>
-          </p:cNvSpPr>
-          <p:nvPr>
-            <p:ph type="body" sz="quarter" idx="18"/>
-          </p:nvPr>
-        </p:nvSpPr>
-        <p:spPr/>
+        </p:txBody>
+      </p:sp>
+      <p:sp>
+        <p:nvSpPr>
+          <p:cNvPr id="7" name="Espace réservé du texte 6"/>
+          <p:cNvSpPr>
+            <a:spLocks noGrp="1"/>
+          </p:cNvSpPr>
+          <p:nvPr>
+            <p:ph type="body" sz="quarter" idx="19"/>
+          </p:nvPr>
+        </p:nvSpPr>
+        <p:spPr>
+          <a:xfrm>
+            <a:off x="6612146" y="2845802"/>
+            <a:ext cx="4557487" cy="3131486"/>
+          </a:xfrm>
+        </p:spPr>
         <p:txBody>
           <a:bodyPr/>
           <a:lstStyle/>
           <a:p>
             <a:r>
-              <a:rPr lang="fr-FR" dirty="0"/>
-              <a:t>Inférence en batch</a:t>
-            </a:r>
-          </a:p>
-        </p:txBody>
-      </p:sp>
-      <p:sp>
-        <p:nvSpPr>
-          <p:cNvPr id="7" name="Espace réservé du texte 6"/>
-          <p:cNvSpPr>
-            <a:spLocks noGrp="1"/>
-          </p:cNvSpPr>
-          <p:nvPr>
-            <p:ph type="body" sz="quarter" idx="19"/>
-          </p:nvPr>
-        </p:nvSpPr>
-        <p:spPr>
-          <a:xfrm>
-            <a:off x="6612146" y="2845802"/>
-            <a:ext cx="4557487" cy="3131486"/>
-          </a:xfrm>
-        </p:spPr>
+              <a:rPr lang="en-US" dirty="0"/>
+              <a:t>Idea: Process data in real time as it is collected.</a:t>
+            </a:r>
+          </a:p>
+          <a:p>
+            <a:pPr marL="285750" indent="-285750">
+              <a:buFont typeface="Arial" panose="020B0604020202020204" pitchFamily="34" charset="0"/>
+              <a:buChar char="•"/>
+            </a:pPr>
+            <a:r>
+              <a:rPr lang="en-US" dirty="0"/>
+              <a:t>Real-time processing</a:t>
+            </a:r>
+          </a:p>
+          <a:p>
+            <a:pPr marL="285750" indent="-285750">
+              <a:buFont typeface="Arial" panose="020B0604020202020204" pitchFamily="34" charset="0"/>
+              <a:buChar char="•"/>
+            </a:pPr>
+            <a:r>
+              <a:rPr lang="en-US" dirty="0"/>
+              <a:t>Requires an efficient preprocessing pipeline</a:t>
+            </a:r>
+          </a:p>
+          <a:p>
+            <a:pPr marL="285750" indent="-285750">
+              <a:buFont typeface="Arial" panose="020B0604020202020204" pitchFamily="34" charset="0"/>
+              <a:buChar char="•"/>
+            </a:pPr>
+            <a:r>
+              <a:rPr lang="en-US" dirty="0"/>
+              <a:t>The need for real-time or near-real-time response limits the complexity of models that can be </a:t>
+            </a:r>
+            <a:r>
+              <a:rPr lang="en-US" dirty="0" smtClean="0"/>
+              <a:t>used</a:t>
+            </a:r>
+          </a:p>
+          <a:p>
+            <a:pPr marL="285750" indent="-285750">
+              <a:buFont typeface="Arial" panose="020B0604020202020204" pitchFamily="34" charset="0"/>
+              <a:buChar char="•"/>
+            </a:pPr>
+            <a:endParaRPr lang="en-US" dirty="0" smtClean="0"/>
+          </a:p>
+          <a:p>
+            <a:endParaRPr lang="en-US" dirty="0"/>
+          </a:p>
+          <a:p>
+            <a:r>
+              <a:rPr lang="en-US" dirty="0"/>
+              <a:t>Examples:</a:t>
+            </a:r>
+          </a:p>
+          <a:p>
+            <a:r>
+              <a:rPr lang="en-US" dirty="0"/>
+              <a:t>Recommendation </a:t>
+            </a:r>
+            <a:r>
+              <a:rPr lang="en-US" dirty="0" smtClean="0"/>
+              <a:t>systems, </a:t>
+            </a:r>
+            <a:r>
+              <a:rPr lang="en-US" dirty="0" err="1" smtClean="0"/>
+              <a:t>Chatbots</a:t>
+            </a:r>
+            <a:endParaRPr lang="en-US" dirty="0"/>
+          </a:p>
+        </p:txBody>
+      </p:sp>
+      <p:sp>
+        <p:nvSpPr>
+          <p:cNvPr id="8" name="Espace réservé du texte 7"/>
+          <p:cNvSpPr>
+            <a:spLocks noGrp="1"/>
+          </p:cNvSpPr>
+          <p:nvPr>
+            <p:ph type="body" sz="quarter" idx="20"/>
+          </p:nvPr>
+        </p:nvSpPr>
+        <p:spPr/>
         <p:txBody>
           <a:bodyPr/>
           <a:lstStyle/>
           <a:p>
             <a:r>
               <a:rPr lang="fr-FR" dirty="0" smtClean="0"/>
-              <a:t>Idée : traiter les données en temps réel au fur et à mesure qu’elles sont collectées.</a:t>
-            </a:r>
-          </a:p>
-          <a:p>
-            <a:endParaRPr lang="fr-FR" dirty="0" smtClean="0"/>
-          </a:p>
-          <a:p>
-            <a:pPr marL="285750" indent="-285750">
-              <a:buFontTx/>
-              <a:buChar char="-"/>
-            </a:pPr>
-            <a:r>
-              <a:rPr lang="fr-FR" dirty="0" smtClean="0"/>
-              <a:t>Temps réel</a:t>
-            </a:r>
-          </a:p>
-          <a:p>
-            <a:pPr marL="285750" indent="-285750">
-              <a:buFontTx/>
-              <a:buChar char="-"/>
-            </a:pPr>
-            <a:r>
-              <a:rPr lang="fr-FR" dirty="0" smtClean="0"/>
-              <a:t>Nécessite une pipeline de </a:t>
+              <a:t>Real-Time (Streaming) </a:t>
             </a:r>
             <a:r>
               <a:rPr lang="fr-FR" dirty="0" err="1" smtClean="0"/>
-              <a:t>préprocessing</a:t>
-            </a:r>
-            <a:r>
-              <a:rPr lang="fr-FR" dirty="0" smtClean="0"/>
-              <a:t> efficace</a:t>
-            </a:r>
-          </a:p>
-          <a:p>
-            <a:pPr marL="285750" indent="-285750">
-              <a:buFontTx/>
-              <a:buChar char="-"/>
-            </a:pPr>
-            <a:r>
-              <a:rPr lang="fr-FR" dirty="0" smtClean="0"/>
-              <a:t>L’exigence de temps réel ou quasi-réel limite la complexité des modèles à utiliser.</a:t>
-            </a:r>
-          </a:p>
-          <a:p>
-            <a:endParaRPr lang="fr-FR" dirty="0"/>
-          </a:p>
-          <a:p>
-            <a:r>
-              <a:rPr lang="fr-FR" dirty="0" smtClean="0"/>
-              <a:t>Exemple :</a:t>
-            </a:r>
-          </a:p>
-          <a:p>
-            <a:r>
-              <a:rPr lang="fr-FR" dirty="0" smtClean="0"/>
-              <a:t>Système de recommandation, </a:t>
-            </a:r>
-            <a:r>
-              <a:rPr lang="fr-FR" dirty="0" err="1" smtClean="0"/>
-              <a:t>chatbot</a:t>
-            </a:r>
-            <a:endParaRPr lang="fr-FR" dirty="0"/>
-          </a:p>
-        </p:txBody>
-      </p:sp>
-      <p:sp>
-        <p:nvSpPr>
-          <p:cNvPr id="8" name="Espace réservé du texte 7"/>
-          <p:cNvSpPr>
-            <a:spLocks noGrp="1"/>
-          </p:cNvSpPr>
-          <p:nvPr>
-            <p:ph type="body" sz="quarter" idx="20"/>
-          </p:nvPr>
-        </p:nvSpPr>
-        <p:spPr/>
-        <p:txBody>
-          <a:bodyPr/>
-          <a:lstStyle/>
-          <a:p>
-            <a:r>
-              <a:rPr lang="fr-FR" dirty="0" smtClean="0"/>
-              <a:t>Streaming sur un </a:t>
-            </a:r>
-            <a:r>
-              <a:rPr lang="fr-FR" dirty="0" err="1" smtClean="0"/>
-              <a:t>endpoint</a:t>
+              <a:t>inference</a:t>
             </a:r>
             <a:endParaRPr lang="fr-FR" dirty="0"/>
           </a:p>
@@ -13948,6 +14778,46 @@
           </a:prstGeom>
         </p:spPr>
       </p:pic>
+      <p:sp>
+        <p:nvSpPr>
+          <p:cNvPr id="11" name="Espace réservé du pied de page 4"/>
+          <p:cNvSpPr>
+            <a:spLocks noGrp="1"/>
+          </p:cNvSpPr>
+          <p:nvPr>
+            <p:ph type="ftr" sz="quarter" idx="3"/>
+          </p:nvPr>
+        </p:nvSpPr>
+        <p:spPr>
+          <a:xfrm>
+            <a:off x="194408" y="6435303"/>
+            <a:ext cx="5672016" cy="365125"/>
+          </a:xfrm>
+        </p:spPr>
+        <p:txBody>
+          <a:bodyPr/>
+          <a:lstStyle/>
+          <a:p>
+            <a:r>
+              <a:rPr lang="en-US" dirty="0" smtClean="0"/>
+              <a:t>2025 </a:t>
+            </a:r>
+            <a:r>
+              <a:rPr lang="en-US" dirty="0" smtClean="0"/>
+              <a:t>| ©</a:t>
+            </a:r>
+            <a:r>
+              <a:rPr lang="en-US" dirty="0" err="1" smtClean="0"/>
+              <a:t>HeadMind</a:t>
+            </a:r>
+            <a:r>
+              <a:rPr lang="en-US" dirty="0" smtClean="0"/>
+              <a:t> Partners</a:t>
+            </a:r>
+            <a:endParaRPr lang="fr-FR" dirty="0"/>
+          </a:p>
+        </p:txBody>
+      </p:sp>
     </p:spTree>
     <p:extLst>
       <p:ext uri="{BB962C8B-B14F-4D97-AF65-F5344CB8AC3E}">
@@ -13988,14 +14858,23 @@
             <p:ph type="title"/>
           </p:nvPr>
         </p:nvSpPr>
-        <p:spPr/>
+        <p:spPr>
+          <a:xfrm>
+            <a:off x="4891733" y="1669002"/>
+            <a:ext cx="6716792" cy="1519966"/>
+          </a:xfrm>
+        </p:spPr>
         <p:txBody>
           <a:bodyPr/>
           <a:lstStyle/>
           <a:p>
             <a:r>
+              <a:rPr lang="fr-FR" dirty="0" err="1" smtClean="0"/>
+              <a:t>Scaling</a:t>
+            </a:r>
+            <a:r>
               <a:rPr lang="fr-FR" dirty="0" smtClean="0"/>
-              <a:t>Montée en charge de l’</a:t>
+              <a:t> up an </a:t>
             </a:r>
             <a:r>
               <a:rPr lang="fr-FR" dirty="0" err="1" smtClean="0"/>
@@ -14021,8 +14900,12 @@
           <a:lstStyle/>
           <a:p>
             <a:r>
+              <a:rPr lang="fr-FR" dirty="0" err="1" smtClean="0"/>
+              <a:t>Using</a:t>
+            </a:r>
+            <a:r>
               <a:rPr lang="fr-FR" dirty="0" smtClean="0"/>
-              <a:t>Utilisation de </a:t>
+              <a:t> </a:t>
             </a:r>
             <a:r>
               <a:rPr lang="fr-FR" dirty="0" err="1" smtClean="0"/>
@@ -14078,12 +14961,24 @@
           <a:lstStyle/>
           <a:p>
             <a:r>
+              <a:rPr lang="fr-FR" dirty="0" err="1" smtClean="0"/>
+              <a:t>Scaling</a:t>
+            </a:r>
+            <a:r>
               <a:rPr lang="fr-FR" dirty="0" smtClean="0"/>
-              <a:t>Montée en charge de l’</a:t>
+              <a:t> up </a:t>
             </a:r>
             <a:r>
               <a:rPr lang="fr-FR" dirty="0" err="1" smtClean="0"/>
               <a:t>endpoint</a:t>
+            </a:r>
+            <a:r>
+              <a:rPr lang="fr-FR" dirty="0" smtClean="0"/>
+              <a:t> </a:t>
+            </a:r>
+            <a:r>
+              <a:rPr lang="fr-FR" dirty="0" err="1" smtClean="0"/>
+              <a:t>capacities</a:t>
             </a:r>
             <a:endParaRPr lang="fr-FR" dirty="0"/>
           </a:p>
@@ -14108,32 +15003,44 @@
               <a:buNone/>
             </a:pPr>
             <a:r>
-              <a:rPr lang="fr-FR" dirty="0" smtClean="0"/>
-              <a:t>On va tester la capacité du service à </a:t>
-            </a:r>
-            <a:r>
-              <a:rPr lang="fr-FR" b="1" dirty="0"/>
-              <a:t>gérer l'augmentation du </a:t>
-            </a:r>
-            <a:r>
-              <a:rPr lang="fr-FR" b="1" dirty="0" smtClean="0"/>
-              <a:t>trafic</a:t>
-            </a:r>
-          </a:p>
-          <a:p>
-            <a:r>
-              <a:rPr lang="fr-FR" dirty="0" smtClean="0"/>
-              <a:t>Envoie de nombreuses requêtes API en parallèles</a:t>
-            </a:r>
-          </a:p>
-          <a:p>
-            <a:r>
-              <a:rPr lang="fr-FR" dirty="0" smtClean="0"/>
-              <a:t>Observation du temps de réponse moyen et du nombre d’erreur</a:t>
-            </a:r>
-          </a:p>
-          <a:p>
-            <a:endParaRPr lang="fr-FR" dirty="0"/>
+              <a:rPr lang="en-US" dirty="0"/>
+              <a:t>We will test the service's ability to </a:t>
+            </a:r>
+            <a:r>
+              <a:rPr lang="en-US" b="1" dirty="0"/>
+              <a:t>handle increased traffic</a:t>
+            </a:r>
+          </a:p>
+          <a:p>
+            <a:r>
+              <a:rPr lang="en-US" dirty="0"/>
+              <a:t>Sending a large number of API requests in parallel</a:t>
+            </a:r>
+          </a:p>
+          <a:p>
+            <a:r>
+              <a:rPr lang="en-US" dirty="0"/>
+              <a:t>Monitoring </a:t>
+            </a:r>
+            <a:r>
+              <a:rPr lang="en-US" dirty="0" smtClean="0"/>
+              <a:t>average </a:t>
+            </a:r>
+            <a:r>
+              <a:rPr lang="en-US" dirty="0"/>
+              <a:t>response time and </a:t>
+            </a:r>
+            <a:r>
+              <a:rPr lang="en-US" dirty="0" smtClean="0"/>
+              <a:t>number </a:t>
+            </a:r>
+            <a:r>
+              <a:rPr lang="en-US" dirty="0"/>
+              <a:t>of errors</a:t>
+            </a:r>
+          </a:p>
+          <a:p>
+            <a:endParaRPr lang="fr-FR" dirty="0" smtClean="0"/>
           </a:p>
           <a:p>
             <a:pPr marL="0" indent="0">
@@ -14141,7 +15048,11 @@
             </a:pPr>
             <a:r>
               <a:rPr lang="fr-FR" dirty="0" smtClean="0"/>
-              <a:t>Utilisation de </a:t>
+              <a:t>Utilisation </a:t>
+            </a:r>
+            <a:r>
+              <a:rPr lang="fr-FR" dirty="0" smtClean="0"/>
+              <a:t>de </a:t>
             </a:r>
             <a:r>
               <a:rPr lang="fr-FR" b="1" dirty="0" err="1" smtClean="0"/>
@@ -14155,20 +15066,71 @@
           <a:p>
             <a:r>
               <a:rPr lang="fr-FR" dirty="0" smtClean="0"/>
-              <a:t>Outil de test de charge Open Source</a:t>
-            </a:r>
-          </a:p>
-          <a:p>
+              <a:t>Open source python </a:t>
+            </a:r>
+            <a:r>
+              <a:rPr lang="fr-FR" dirty="0" err="1" smtClean="0"/>
+              <a:t>library</a:t>
+            </a:r>
             <a:r>
               <a:rPr lang="fr-FR" dirty="0" smtClean="0"/>
-              <a:t>Permet de simuler de nombreux utilisateurs simultanés</a:t>
-            </a:r>
-          </a:p>
-          <a:p>
+              <a:t> for </a:t>
+            </a:r>
+            <a:r>
+              <a:rPr lang="fr-FR" dirty="0" err="1" smtClean="0"/>
+              <a:t>load</a:t>
+            </a:r>
             <a:r>
               <a:rPr lang="fr-FR" dirty="0" smtClean="0"/>
-              <a:t>Interface intuitive</a:t>
-            </a:r>
+              <a:t> </a:t>
+            </a:r>
+            <a:r>
+              <a:rPr lang="fr-FR" dirty="0" err="1" smtClean="0"/>
+              <a:t>testing</a:t>
+            </a:r>
+            <a:endParaRPr lang="fr-FR" dirty="0" smtClean="0"/>
+          </a:p>
+          <a:p>
+            <a:r>
+              <a:rPr lang="fr-FR" dirty="0" err="1" smtClean="0"/>
+              <a:t>Allows</a:t>
+            </a:r>
+            <a:r>
+              <a:rPr lang="fr-FR" dirty="0" smtClean="0"/>
+              <a:t> simulation of multiple </a:t>
+            </a:r>
+            <a:r>
+              <a:rPr lang="fr-FR" dirty="0" err="1" smtClean="0"/>
+              <a:t>simultaneous</a:t>
+            </a:r>
+            <a:r>
+              <a:rPr lang="fr-FR" dirty="0" smtClean="0"/>
+              <a:t> </a:t>
+            </a:r>
+            <a:r>
+              <a:rPr lang="fr-FR" dirty="0" err="1" smtClean="0"/>
+              <a:t>users</a:t>
+            </a:r>
+            <a:endParaRPr lang="fr-FR" dirty="0" smtClean="0"/>
+          </a:p>
+          <a:p>
+            <a:r>
+              <a:rPr lang="fr-FR" dirty="0" err="1" smtClean="0"/>
+              <a:t>Praised</a:t>
+            </a:r>
+            <a:r>
+              <a:rPr lang="fr-FR" dirty="0" smtClean="0"/>
+              <a:t> for </a:t>
+            </a:r>
+            <a:r>
+              <a:rPr lang="fr-FR" dirty="0" err="1" smtClean="0"/>
+              <a:t>its</a:t>
+            </a:r>
+            <a:r>
+              <a:rPr lang="fr-FR" dirty="0" smtClean="0"/>
+              <a:t> intuitive interface</a:t>
+            </a:r>
+            <a:endParaRPr lang="fr-FR" dirty="0" smtClean="0"/>
           </a:p>
           <a:p>
             <a:endParaRPr lang="fr-FR" dirty="0" smtClean="0"/>
@@ -14206,7 +15168,7 @@
       </p:sp>
       <p:sp>
         <p:nvSpPr>
-          <p:cNvPr id="5" name="Espace réservé du pied de page 4"/>
+          <p:cNvPr id="7" name="Espace réservé du pied de page 4"/>
           <p:cNvSpPr>
             <a:spLocks noGrp="1"/>
           </p:cNvSpPr>
@@ -14214,14 +15176,31 @@
             <p:ph type="ftr" sz="quarter" idx="3"/>
           </p:nvPr>
         </p:nvSpPr>
-        <p:spPr/>
+        <p:spPr>
+          <a:xfrm>
+            <a:off x="194408" y="6435303"/>
+            <a:ext cx="5672016" cy="365125"/>
+          </a:xfrm>
+        </p:spPr>
         <p:txBody>
           <a:bodyPr/>
           <a:lstStyle/>
           <a:p>
             <a:r>
-              <a:rPr lang="en-US" smtClean="0"/>
-              <a:t>2024 | ©HeadMind Partners</a:t>
+              <a:rPr lang="en-US" dirty="0" smtClean="0"/>
+              <a:t>2025 </a:t>
+            </a:r>
+            <a:r>
+              <a:rPr lang="en-US" dirty="0" smtClean="0"/>
+              <a:t>| ©</a:t>
+            </a:r>
+            <a:r>
+              <a:rPr lang="en-US" dirty="0" err="1" smtClean="0"/>
+              <a:t>HeadMind</a:t>
+            </a:r>
+            <a:r>
+              <a:rPr lang="en-US" dirty="0" smtClean="0"/>
+              <a:t> Partners</a:t>
             </a:r>
             <a:endParaRPr lang="fr-FR" dirty="0"/>
           </a:p>
@@ -14229,26 +15208,43 @@
       </p:sp>
       <p:pic>
         <p:nvPicPr>
-          <p:cNvPr id="6" name="Image 5"/>
+          <p:cNvPr id="3074" name="Picture 2" descr="Locust (logiciel) — Wikipédia"/>
           <p:cNvPicPr>
-            <a:picLocks noChangeAspect="1"/>
+            <a:picLocks noChangeAspect="1" noChangeArrowheads="1"/>
           </p:cNvPicPr>
           <p:nvPr/>
         </p:nvPicPr>
         <p:blipFill>
-          <a:blip r:embed="rId2"/>
+          <a:blip r:embed="rId2" cstate="print">
+            <a:extLst>
+              <a:ext uri="{28A0092B-C50C-407E-A947-70E740481C1C}">
+                <a14:useLocalDpi xmlns:a14="http://schemas.microsoft.com/office/drawing/2010/main" val="0"/>
+              </a:ext>
+            </a:extLst>
+          </a:blip>
+          <a:srcRect/>
           <a:stretch>
             <a:fillRect/>
           </a:stretch>
         </p:blipFill>
-        <p:spPr>
-          <a:xfrm>
-            <a:off x="7505700" y="3525774"/>
-            <a:ext cx="1371600" cy="1179576"/>
+        <p:spPr bwMode="auto">
+          <a:xfrm>
+            <a:off x="6154331" y="3093615"/>
+            <a:ext cx="5510288" cy="3341688"/>
           </a:xfrm>
           <a:prstGeom prst="rect">
             <a:avLst/>
           </a:prstGeom>
+          <a:noFill/>
+          <a:extLst>
+            <a:ext uri="{909E8E84-426E-40DD-AFC4-6F175D3DCCD1}">
+              <a14:hiddenFill xmlns:a14="http://schemas.microsoft.com/office/drawing/2010/main">
+                <a:solidFill>
+                  <a:srgbClr val="FFFFFF"/>
+                </a:solidFill>
+              </a14:hiddenFill>
+            </a:ext>
+          </a:extLst>
         </p:spPr>
       </p:pic>
     </p:spTree>
@@ -14368,8 +15364,9 @@
           <a:p>
             <a:r>
               <a:rPr lang="fr-FR" dirty="0" smtClean="0"/>
-              <a:t>Introduction et objectifs</a:t>
-            </a:r>
+              <a:t>Introduction and goals</a:t>
+            </a:r>
+            <a:endParaRPr lang="fr-FR" dirty="0" smtClean="0"/>
           </a:p>
         </p:txBody>
       </p:sp>
@@ -14395,7 +15392,7 @@
           <a:p>
             <a:r>
               <a:rPr lang="fr-FR" dirty="0" smtClean="0"/>
-              <a:t>Entraînement d’un modèle sur un cloud</a:t>
+              <a:t>Model training on the cloud</a:t>
             </a:r>
             <a:endParaRPr lang="fr-FR" dirty="0"/>
           </a:p>
@@ -14422,8 +15419,12 @@
           <a:lstStyle/>
           <a:p>
             <a:r>
+              <a:rPr lang="fr-FR" dirty="0" err="1" smtClean="0"/>
+              <a:t>Deploying</a:t>
+            </a:r>
+            <a:r>
               <a:rPr lang="fr-FR" dirty="0" smtClean="0"/>
-              <a:t>Déploiement sur un </a:t>
+              <a:t> an </a:t>
             </a:r>
             <a:r>
               <a:rPr lang="fr-FR" dirty="0" err="1" smtClean="0"/>
@@ -14449,12 +15450,12 @@
           <a:lstStyle/>
           <a:p>
             <a:r>
+              <a:rPr lang="fr-FR" dirty="0" smtClean="0"/>
+              <a:t>Cloud </a:t>
+            </a:r>
+            <a:r>
               <a:rPr lang="fr-FR" dirty="0" err="1" smtClean="0"/>
-              <a:t>Intérets</a:t>
-            </a:r>
-            <a:r>
-              <a:rPr lang="fr-FR" dirty="0" smtClean="0"/>
-              <a:t> du cloud</a:t>
+              <a:t>advantages</a:t>
             </a:r>
             <a:endParaRPr lang="fr-FR" dirty="0"/>
           </a:p>
@@ -14477,7 +15478,7 @@
           <a:p>
             <a:r>
               <a:rPr lang="fr-FR" dirty="0" smtClean="0"/>
-              <a:t>Données, Azure Machine Learning</a:t>
+              <a:t>Data, Azure Machine Learning</a:t>
             </a:r>
             <a:endParaRPr lang="fr-FR" dirty="0"/>
           </a:p>
@@ -14499,15 +15500,17 @@
           <a:lstStyle/>
           <a:p>
             <a:r>
-              <a:rPr lang="fr-FR" dirty="0" smtClean="0"/>
-              <a:t>F</a:t>
-            </a:r>
-            <a:r>
-              <a:rPr lang="fr-FR" dirty="0"/>
-              <a:t>onctionnement, Inférence par batch vs streaming</a:t>
-            </a:r>
-          </a:p>
-          <a:p>
+              <a:rPr lang="en-US" dirty="0"/>
+              <a:t>Specificities, Batch inference </a:t>
+            </a:r>
+            <a:r>
+              <a:rPr lang="en-US" dirty="0" smtClean="0"/>
+              <a:t>V.S. </a:t>
+            </a:r>
+            <a:r>
+              <a:rPr lang="en-US" dirty="0"/>
+              <a:t>streaming</a:t>
+            </a:r>
             <a:endParaRPr lang="fr-FR" dirty="0"/>
           </a:p>
         </p:txBody>
@@ -14575,12 +15578,16 @@
           <a:lstStyle/>
           <a:p>
             <a:r>
-              <a:rPr lang="fr-FR" dirty="0"/>
-              <a:t>Montée en charge d’un </a:t>
-            </a:r>
-            <a:r>
-              <a:rPr lang="fr-FR" dirty="0" err="1"/>
-              <a:t>endpoint</a:t>
+              <a:rPr lang="fr-FR" dirty="0" err="1" smtClean="0"/>
+              <a:t>Endpoint</a:t>
+            </a:r>
+            <a:r>
+              <a:rPr lang="fr-FR" dirty="0" smtClean="0"/>
+              <a:t> </a:t>
+            </a:r>
+            <a:r>
+              <a:rPr lang="fr-FR" dirty="0" err="1" smtClean="0"/>
+              <a:t>scaling</a:t>
             </a:r>
             <a:endParaRPr lang="fr-FR" dirty="0"/>
           </a:p>
@@ -14645,8 +15652,12 @@
           <a:lstStyle/>
           <a:p>
             <a:r>
+              <a:rPr lang="fr-FR" dirty="0" err="1" smtClean="0"/>
+              <a:t>Definition</a:t>
+            </a:r>
+            <a:r>
               <a:rPr lang="fr-FR" dirty="0" smtClean="0"/>
-              <a:t>Définition et test</a:t>
+              <a:t> &amp; test</a:t>
             </a:r>
             <a:endParaRPr lang="fr-FR" dirty="0"/>
           </a:p>
@@ -14744,12 +15755,12 @@
       </p:sp>
       <p:sp>
         <p:nvSpPr>
-          <p:cNvPr id="22" name="Espace réservé du pied de page 21"/>
-          <p:cNvSpPr>
-            <a:spLocks noGrp="1"/>
-          </p:cNvSpPr>
-          <p:nvPr>
-            <p:ph type="ftr" sz="quarter" idx="3"/>
+          <p:cNvPr id="23" name="Espace réservé du contenu 22"/>
+          <p:cNvSpPr>
+            <a:spLocks noGrp="1"/>
+          </p:cNvSpPr>
+          <p:nvPr>
+            <p:ph sz="quarter" idx="28"/>
           </p:nvPr>
         </p:nvSpPr>
         <p:spPr/>
@@ -14757,38 +15768,7 @@
           <a:bodyPr/>
           <a:lstStyle/>
           <a:p>
-            <a:r>
-              <a:rPr lang="en-US" dirty="0" smtClean="0"/>
-              <a:t>2024 | ©</a:t>
-            </a:r>
-            <a:r>
-              <a:rPr lang="en-US" dirty="0" err="1" smtClean="0"/>
-              <a:t>HeadMind</a:t>
-            </a:r>
-            <a:r>
-              <a:rPr lang="en-US" dirty="0" smtClean="0"/>
-              <a:t> Partners</a:t>
-            </a:r>
             <a:endParaRPr lang="fr-FR" dirty="0"/>
-          </a:p>
-        </p:txBody>
-      </p:sp>
-      <p:sp>
-        <p:nvSpPr>
-          <p:cNvPr id="23" name="Espace réservé du contenu 22"/>
-          <p:cNvSpPr>
-            <a:spLocks noGrp="1"/>
-          </p:cNvSpPr>
-          <p:nvPr>
-            <p:ph sz="quarter" idx="28"/>
-          </p:nvPr>
-        </p:nvSpPr>
-        <p:spPr/>
-        <p:txBody>
-          <a:bodyPr/>
-          <a:lstStyle/>
-          <a:p>
-            <a:endParaRPr lang="fr-FR"/>
           </a:p>
         </p:txBody>
       </p:sp>
@@ -14868,8 +15848,16 @@
           <a:lstStyle/>
           <a:p>
             <a:r>
+              <a:rPr lang="fr-FR" dirty="0" err="1"/>
+              <a:t>Session’s</a:t>
+            </a:r>
+            <a:r>
+              <a:rPr lang="fr-FR" dirty="0"/>
+              <a:t> goals and </a:t>
+            </a:r>
+            <a:r>
               <a:rPr lang="fr-FR" dirty="0" smtClean="0"/>
-              <a:t>Objectifs de la séance et cloud </a:t>
+              <a:t>cloud </a:t>
             </a:r>
             <a:r>
               <a:rPr lang="fr-FR" dirty="0" err="1" smtClean="0"/>
@@ -14926,7 +15914,11 @@
           <a:p>
             <a:r>
               <a:rPr lang="fr-FR" dirty="0" smtClean="0"/>
-              <a:t>Introduction et objectifs</a:t>
+              <a:t>Introduction </a:t>
+            </a:r>
+            <a:r>
+              <a:rPr lang="fr-FR" dirty="0" smtClean="0"/>
+              <a:t>&amp; objectives</a:t>
             </a:r>
             <a:endParaRPr lang="fr-FR" dirty="0"/>
           </a:p>
@@ -14963,29 +15955,6 @@
       </p:sp>
       <p:sp>
         <p:nvSpPr>
-          <p:cNvPr id="5" name="Espace réservé du pied de page 4"/>
-          <p:cNvSpPr>
-            <a:spLocks noGrp="1"/>
-          </p:cNvSpPr>
-          <p:nvPr>
-            <p:ph type="ftr" sz="quarter" idx="3"/>
-          </p:nvPr>
-        </p:nvSpPr>
-        <p:spPr/>
-        <p:txBody>
-          <a:bodyPr/>
-          <a:lstStyle/>
-          <a:p>
-            <a:r>
-              <a:rPr lang="en-US" smtClean="0"/>
-              <a:t>2024 | ©HeadMind Partners</a:t>
-            </a:r>
-            <a:endParaRPr lang="fr-FR" dirty="0"/>
-          </a:p>
-        </p:txBody>
-      </p:sp>
-      <p:sp>
-        <p:nvSpPr>
           <p:cNvPr id="7" name="ZoneTexte 6"/>
           <p:cNvSpPr txBox="1"/>
           <p:nvPr/>
@@ -15012,8 +15981,12 @@
               </a:lnSpc>
             </a:pPr>
             <a:r>
+              <a:rPr lang="fr-FR" sz="1400" dirty="0" err="1" smtClean="0"/>
+              <a:t>Today’s</a:t>
+            </a:r>
+            <a:r>
               <a:rPr lang="fr-FR" sz="1400" dirty="0" smtClean="0"/>
-              <a:t>Aujourd’hui, nous allons :</a:t>
+              <a:t> agenda:</a:t>
             </a:r>
             <a:endParaRPr lang="fr-FR" dirty="0" smtClean="0"/>
           </a:p>
@@ -15027,31 +16000,19 @@
             </a:pPr>
             <a:r>
               <a:rPr lang="fr-FR" sz="1400" dirty="0" smtClean="0"/>
-              <a:t>Entraîner </a:t>
-            </a:r>
-            <a:r>
-              <a:rPr lang="fr-FR" sz="1400" dirty="0"/>
-              <a:t>un </a:t>
+              <a:t>Train a </a:t>
+            </a:r>
+            <a:r>
+              <a:rPr lang="fr-FR" sz="1400" dirty="0" err="1" smtClean="0"/>
+              <a:t>neuronnal</a:t>
             </a:r>
             <a:r>
               <a:rPr lang="fr-FR" sz="1400" dirty="0" smtClean="0"/>
-              <a:t>réseau de neurones </a:t>
-            </a:r>
-            <a:r>
-              <a:rPr lang="fr-FR" sz="1400" dirty="0"/>
-              <a:t>sur </a:t>
-            </a:r>
-            <a:r>
-              <a:rPr lang="fr-FR" sz="1400" dirty="0" smtClean="0"/>
-              <a:t>un </a:t>
+              <a:t> network on a </a:t>
             </a:r>
             <a:r>
               <a:rPr lang="fr-FR" sz="1400" dirty="0" err="1" smtClean="0"/>
               <a:t>dataset</a:t>
-            </a:r>
-            <a:r>
-              <a:rPr lang="fr-FR" sz="1400" dirty="0" smtClean="0"/>
-              <a:t>.</a:t>
             </a:r>
             <a:endParaRPr lang="fr-FR" sz="1400" dirty="0"/>
           </a:p>
@@ -15064,20 +16025,24 @@
               <a:buChar char="•"/>
             </a:pPr>
             <a:r>
-              <a:rPr lang="fr-FR" sz="1400" dirty="0"/>
-              <a:t>Optimiser les </a:t>
-            </a:r>
-            <a:r>
-              <a:rPr lang="fr-FR" sz="1400" dirty="0" err="1"/>
-              <a:t>hyperparamètres</a:t>
-            </a:r>
-            <a:r>
-              <a:rPr lang="fr-FR" sz="1400" dirty="0"/>
+              <a:rPr lang="fr-FR" sz="1400" dirty="0" err="1" smtClean="0"/>
+              <a:t>Optimising</a:t>
+            </a:r>
+            <a:r>
+              <a:rPr lang="fr-FR" sz="1400" dirty="0" smtClean="0"/>
               <a:t> </a:t>
             </a:r>
             <a:r>
+              <a:rPr lang="fr-FR" sz="1400" dirty="0" err="1" smtClean="0"/>
+              <a:t>its</a:t>
+            </a:r>
+            <a:r>
               <a:rPr lang="fr-FR" sz="1400" dirty="0" smtClean="0"/>
-              <a:t>de l’entraînement</a:t>
+              <a:t> </a:t>
+            </a:r>
+            <a:r>
+              <a:rPr lang="fr-FR" sz="1400" dirty="0" err="1" smtClean="0"/>
+              <a:t>hyperparameters</a:t>
             </a:r>
             <a:endParaRPr lang="fr-FR" sz="1400" dirty="0"/>
           </a:p>
@@ -15090,9 +16055,26 @@
               <a:buChar char="•"/>
             </a:pPr>
             <a:r>
-              <a:rPr lang="fr-FR" sz="1400" dirty="0"/>
-              <a:t>Déployer en temps réel (online) et batch.</a:t>
-            </a:r>
+              <a:rPr lang="fr-FR" sz="1400" dirty="0" err="1" smtClean="0"/>
+              <a:t>Deploying</a:t>
+            </a:r>
+            <a:r>
+              <a:rPr lang="fr-FR" sz="1400" dirty="0" smtClean="0"/>
+              <a:t> for </a:t>
+            </a:r>
+            <a:r>
+              <a:rPr lang="fr-FR" sz="1400" dirty="0" err="1" smtClean="0"/>
+              <a:t>both</a:t>
+            </a:r>
+            <a:r>
+              <a:rPr lang="fr-FR" sz="1400" dirty="0" smtClean="0"/>
+              <a:t> Real-Time &amp; Batch </a:t>
+            </a:r>
+            <a:r>
+              <a:rPr lang="fr-FR" sz="1400" dirty="0" err="1" smtClean="0"/>
+              <a:t>inference</a:t>
+            </a:r>
+            <a:endParaRPr lang="fr-FR" sz="1400" dirty="0"/>
           </a:p>
           <a:p>
             <a:pPr marL="285750" indent="-285750">
@@ -15103,13 +16085,26 @@
               <a:buChar char="•"/>
             </a:pPr>
             <a:r>
-              <a:rPr lang="fr-FR" sz="1400" dirty="0"/>
-              <a:t>Tester la montée en </a:t>
+              <a:rPr lang="fr-FR" sz="1400" dirty="0" err="1" smtClean="0"/>
+              <a:t>Load</a:t>
             </a:r>
             <a:r>
               <a:rPr lang="fr-FR" sz="1400" dirty="0" smtClean="0"/>
-              <a:t>charge</a:t>
-            </a:r>
+              <a:t> </a:t>
+            </a:r>
+            <a:r>
+              <a:rPr lang="fr-FR" sz="1400" dirty="0" err="1" smtClean="0"/>
+              <a:t>testing</a:t>
+            </a:r>
+            <a:r>
+              <a:rPr lang="fr-FR" sz="1400" dirty="0" smtClean="0"/>
+              <a:t> the </a:t>
+            </a:r>
+            <a:r>
+              <a:rPr lang="fr-FR" sz="1400" dirty="0" err="1" smtClean="0"/>
+              <a:t>scaling</a:t>
+            </a:r>
+            <a:endParaRPr lang="fr-FR" sz="1400" dirty="0" smtClean="0"/>
           </a:p>
           <a:p>
             <a:pPr marL="285750" indent="-285750">
@@ -15128,8 +16123,52 @@
               </a:lnSpc>
             </a:pPr>
             <a:r>
+              <a:rPr lang="fr-FR" sz="1400" dirty="0" err="1" smtClean="0"/>
+              <a:t>These</a:t>
+            </a:r>
+            <a:r>
               <a:rPr lang="fr-FR" sz="1400" dirty="0" smtClean="0"/>
-              <a:t>Ces étapes vont être effectuées sur le cloud Azure.</a:t>
+              <a:t> </a:t>
+            </a:r>
+            <a:r>
+              <a:rPr lang="fr-FR" sz="1400" dirty="0" err="1" smtClean="0"/>
+              <a:t>steps</a:t>
+            </a:r>
+            <a:r>
+              <a:rPr lang="fr-FR" sz="1400" dirty="0" smtClean="0"/>
+              <a:t> </a:t>
+            </a:r>
+            <a:r>
+              <a:rPr lang="fr-FR" sz="1400" dirty="0" err="1" smtClean="0"/>
+              <a:t>will</a:t>
+            </a:r>
+            <a:r>
+              <a:rPr lang="fr-FR" sz="1400" dirty="0" smtClean="0"/>
+              <a:t> </a:t>
+            </a:r>
+            <a:r>
+              <a:rPr lang="fr-FR" sz="1400" dirty="0" err="1" smtClean="0"/>
+              <a:t>be</a:t>
+            </a:r>
+            <a:r>
+              <a:rPr lang="fr-FR" sz="1400" dirty="0" smtClean="0"/>
+              <a:t> </a:t>
+            </a:r>
+            <a:r>
+              <a:rPr lang="fr-FR" sz="1400" dirty="0" err="1" smtClean="0"/>
+              <a:t>done</a:t>
+            </a:r>
+            <a:r>
+              <a:rPr lang="fr-FR" sz="1400" dirty="0" smtClean="0"/>
+              <a:t> </a:t>
+            </a:r>
+            <a:r>
+              <a:rPr lang="fr-FR" sz="1400" dirty="0" err="1" smtClean="0"/>
+              <a:t>using</a:t>
+            </a:r>
+            <a:r>
+              <a:rPr lang="fr-FR" sz="1400" dirty="0" smtClean="0"/>
+              <a:t> Azure Cloud</a:t>
             </a:r>
             <a:endParaRPr lang="fr-FR" sz="1400" dirty="0"/>
           </a:p>
@@ -15276,6 +16315,46 @@
           </a:prstGeom>
         </p:spPr>
       </p:pic>
+      <p:sp>
+        <p:nvSpPr>
+          <p:cNvPr id="9" name="Espace réservé du pied de page 4"/>
+          <p:cNvSpPr>
+            <a:spLocks noGrp="1"/>
+          </p:cNvSpPr>
+          <p:nvPr>
+            <p:ph type="ftr" sz="quarter" idx="3"/>
+          </p:nvPr>
+        </p:nvSpPr>
+        <p:spPr>
+          <a:xfrm>
+            <a:off x="194408" y="6435303"/>
+            <a:ext cx="5672016" cy="365125"/>
+          </a:xfrm>
+        </p:spPr>
+        <p:txBody>
+          <a:bodyPr/>
+          <a:lstStyle/>
+          <a:p>
+            <a:r>
+              <a:rPr lang="en-US" dirty="0" smtClean="0"/>
+              <a:t>2025 </a:t>
+            </a:r>
+            <a:r>
+              <a:rPr lang="en-US" dirty="0" smtClean="0"/>
+              <a:t>| ©</a:t>
+            </a:r>
+            <a:r>
+              <a:rPr lang="en-US" dirty="0" err="1" smtClean="0"/>
+              <a:t>HeadMind</a:t>
+            </a:r>
+            <a:r>
+              <a:rPr lang="en-US" dirty="0" smtClean="0"/>
+              <a:t> Partners</a:t>
+            </a:r>
+            <a:endParaRPr lang="fr-FR" dirty="0"/>
+          </a:p>
+        </p:txBody>
+      </p:sp>
     </p:spTree>
     <p:extLst>
       <p:ext uri="{BB962C8B-B14F-4D97-AF65-F5344CB8AC3E}">
@@ -15330,7 +16409,11 @@
           <a:p>
             <a:r>
               <a:rPr lang="fr-FR" dirty="0" smtClean="0"/>
-              <a:t>Introduction et objectifs</a:t>
+              <a:t>Introduction </a:t>
+            </a:r>
+            <a:r>
+              <a:rPr lang="fr-FR" dirty="0" smtClean="0"/>
+              <a:t>&amp; objectives</a:t>
             </a:r>
             <a:endParaRPr lang="fr-FR" dirty="0"/>
           </a:p>
@@ -15367,29 +16450,6 @@
       </p:sp>
       <p:sp>
         <p:nvSpPr>
-          <p:cNvPr id="5" name="Espace réservé du pied de page 4"/>
-          <p:cNvSpPr>
-            <a:spLocks noGrp="1"/>
-          </p:cNvSpPr>
-          <p:nvPr>
-            <p:ph type="ftr" sz="quarter" idx="3"/>
-          </p:nvPr>
-        </p:nvSpPr>
-        <p:spPr/>
-        <p:txBody>
-          <a:bodyPr/>
-          <a:lstStyle/>
-          <a:p>
-            <a:r>
-              <a:rPr lang="en-US" smtClean="0"/>
-              <a:t>2024 | ©HeadMind Partners</a:t>
-            </a:r>
-            <a:endParaRPr lang="fr-FR" dirty="0"/>
-          </a:p>
-        </p:txBody>
-      </p:sp>
-      <p:sp>
-        <p:nvSpPr>
           <p:cNvPr id="7" name="ZoneTexte 6"/>
           <p:cNvSpPr txBox="1"/>
           <p:nvPr/>
@@ -15417,9 +16477,16 @@
             </a:pPr>
             <a:r>
               <a:rPr lang="fr-FR" sz="1600" dirty="0" smtClean="0"/>
-              <a:t>Fournisseurs majeurs :</a:t>
-            </a:r>
-            <a:endParaRPr lang="fr-FR" sz="2000" dirty="0" smtClean="0"/>
+              <a:t>Major </a:t>
+            </a:r>
+            <a:r>
+              <a:rPr lang="fr-FR" sz="1600" dirty="0" err="1" smtClean="0"/>
+              <a:t>suppliers</a:t>
+            </a:r>
+            <a:r>
+              <a:rPr lang="fr-FR" sz="1600" dirty="0" smtClean="0"/>
+              <a:t> :</a:t>
+            </a:r>
           </a:p>
           <a:p>
             <a:pPr marL="285750" indent="-285750">
@@ -15430,10 +16497,34 @@
               <a:buChar char="•"/>
             </a:pPr>
             <a:r>
+              <a:rPr lang="fr-FR" sz="1400" dirty="0" err="1"/>
+              <a:t>Awazon</a:t>
+            </a:r>
+            <a:r>
+              <a:rPr lang="fr-FR" sz="1400" dirty="0"/>
+              <a:t> Web Services (AWS) (~30% </a:t>
+            </a:r>
+            <a:r>
+              <a:rPr lang="fr-FR" sz="1400" dirty="0" err="1"/>
+              <a:t>market</a:t>
+            </a:r>
+            <a:r>
+              <a:rPr lang="fr-FR" sz="1400" dirty="0"/>
+              <a:t> </a:t>
+            </a:r>
+            <a:r>
+              <a:rPr lang="fr-FR" sz="1400" dirty="0" err="1" smtClean="0"/>
+              <a:t>share</a:t>
+            </a:r>
+            <a:r>
               <a:rPr lang="fr-FR" sz="1400" dirty="0" smtClean="0"/>
-              <a:t>Microsoft Azure</a:t>
-            </a:r>
-            <a:endParaRPr lang="fr-FR" sz="1400" dirty="0"/>
+              <a:t>*)</a:t>
+            </a:r>
+            <a:endParaRPr lang="fr-FR" sz="2800" dirty="0">
+              <a:latin typeface="Franklin Gothic Book" panose="020B0503020102020204" pitchFamily="34" charset="0"/>
+              <a:ea typeface="+mj-ea"/>
+              <a:cs typeface="Franklin Gothic Book" panose="020B0503020102020204" pitchFamily="34" charset="0"/>
+            </a:endParaRPr>
           </a:p>
           <a:p>
             <a:pPr marL="285750" indent="-285750">
@@ -15444,14 +16535,34 @@
               <a:buChar char="•"/>
             </a:pPr>
             <a:r>
+              <a:rPr lang="fr-FR" sz="1400" dirty="0" smtClean="0"/>
+              <a:t>Microsoft </a:t>
+            </a:r>
+            <a:r>
+              <a:rPr lang="fr-FR" sz="1400" dirty="0"/>
+              <a:t>Azure </a:t>
+            </a:r>
+            <a:r>
+              <a:rPr lang="fr-FR" sz="1400" dirty="0" smtClean="0"/>
+              <a:t>(~21% </a:t>
+            </a:r>
+            <a:r>
+              <a:rPr lang="fr-FR" sz="1400" dirty="0" err="1"/>
+              <a:t>market</a:t>
+            </a:r>
+            <a:r>
+              <a:rPr lang="fr-FR" sz="1400" dirty="0"/>
+              <a:t> </a:t>
+            </a:r>
+            <a:r>
               <a:rPr lang="fr-FR" sz="1400" dirty="0" err="1" smtClean="0"/>
-              <a:t>Awazon</a:t>
+              <a:t>share</a:t>
             </a:r>
             <a:r>
               <a:rPr lang="fr-FR" sz="1400" dirty="0" smtClean="0"/>
-              <a:t> Web Services (AWS)</a:t>
-            </a:r>
-            <a:endParaRPr lang="fr-FR" sz="1400" dirty="0"/>
+              <a:t>*)</a:t>
+            </a:r>
+            <a:endParaRPr lang="fr-FR" sz="1400" dirty="0" smtClean="0"/>
           </a:p>
           <a:p>
             <a:pPr marL="285750" indent="-285750">
@@ -15463,7 +16574,35 @@
             </a:pPr>
             <a:r>
               <a:rPr lang="fr-FR" sz="1400" dirty="0" smtClean="0"/>
-              <a:t>Google Cloud Platform (GCP)</a:t>
+              <a:t>Google </a:t>
+            </a:r>
+            <a:r>
+              <a:rPr lang="fr-FR" sz="1400" dirty="0" smtClean="0"/>
+              <a:t>Cloud Platform (GCP</a:t>
+            </a:r>
+            <a:r>
+              <a:rPr lang="fr-FR" sz="1400" dirty="0"/>
+              <a:t>) </a:t>
+            </a:r>
+            <a:r>
+              <a:rPr lang="fr-FR" sz="1400" dirty="0" smtClean="0"/>
+              <a:t>(~12% </a:t>
+            </a:r>
+            <a:r>
+              <a:rPr lang="fr-FR" sz="1400" dirty="0" err="1"/>
+              <a:t>market</a:t>
+            </a:r>
+            <a:r>
+              <a:rPr lang="fr-FR" sz="1400" dirty="0"/>
+              <a:t> </a:t>
+            </a:r>
+            <a:r>
+              <a:rPr lang="fr-FR" sz="1400" dirty="0" err="1" smtClean="0"/>
+              <a:t>share</a:t>
+            </a:r>
+            <a:r>
+              <a:rPr lang="fr-FR" sz="1400" dirty="0" smtClean="0"/>
+              <a:t>*)</a:t>
             </a:r>
             <a:endParaRPr lang="fr-FR" sz="1400" dirty="0"/>
           </a:p>
@@ -15474,8 +16613,20 @@
               </a:lnSpc>
             </a:pPr>
             <a:r>
+              <a:rPr lang="fr-FR" sz="1400" dirty="0" err="1" smtClean="0"/>
+              <a:t>We</a:t>
+            </a:r>
+            <a:r>
               <a:rPr lang="fr-FR" sz="1400" dirty="0" smtClean="0"/>
-              <a:t>Nous allons travailler sur le cloud Azure.</a:t>
+              <a:t> </a:t>
+            </a:r>
+            <a:r>
+              <a:rPr lang="fr-FR" sz="1400" dirty="0" err="1" smtClean="0"/>
+              <a:t>will</a:t>
+            </a:r>
+            <a:r>
+              <a:rPr lang="fr-FR" sz="1400" dirty="0" smtClean="0"/>
+              <a:t> continue on Azure.</a:t>
             </a:r>
             <a:endParaRPr lang="fr-FR" sz="1400" dirty="0"/>
           </a:p>
@@ -15493,7 +16644,7 @@
         <p:spPr>
           <a:xfrm>
             <a:off x="751652" y="1299558"/>
-            <a:ext cx="6267797" cy="1431161"/>
+            <a:ext cx="6267797" cy="1754326"/>
           </a:xfrm>
           <a:prstGeom prst="rect">
             <a:avLst/>
@@ -15512,8 +16663,12 @@
               </a:lnSpc>
             </a:pPr>
             <a:r>
+              <a:rPr lang="fr-FR" sz="1600" dirty="0" err="1" smtClean="0"/>
+              <a:t>What’s</a:t>
+            </a:r>
+            <a:r>
               <a:rPr lang="fr-FR" sz="1600" dirty="0" smtClean="0"/>
-              <a:t>Qu’est ce qu’un </a:t>
+              <a:t> a </a:t>
             </a:r>
             <a:r>
               <a:rPr lang="fr-FR" sz="1600" b="1" dirty="0" smtClean="0"/>
@@ -15521,7 +16676,11 @@
             </a:r>
             <a:r>
               <a:rPr lang="fr-FR" sz="1600" dirty="0" smtClean="0"/>
-              <a:t> ? </a:t>
+              <a:t> </a:t>
+            </a:r>
+            <a:r>
+              <a:rPr lang="fr-FR" sz="1600" dirty="0" smtClean="0"/>
+              <a:t>? </a:t>
             </a:r>
             <a:endParaRPr lang="fr-FR" sz="2000" dirty="0" smtClean="0"/>
           </a:p>
@@ -15534,31 +16693,21 @@
               <a:buChar char="•"/>
             </a:pPr>
             <a:r>
-              <a:rPr lang="fr-FR" sz="1400" dirty="0"/>
-              <a:t>Ensemble de ressources informatiques (calcul, stockage, réseau) accessibles à distance via </a:t>
-            </a:r>
-            <a:r>
-              <a:rPr lang="fr-FR" sz="1400" dirty="0" smtClean="0"/>
-              <a:t>Internet</a:t>
-            </a:r>
-          </a:p>
-          <a:p>
-            <a:pPr marL="285750" indent="-285750">
-              <a:lnSpc>
-                <a:spcPct val="150000"/>
-              </a:lnSpc>
-              <a:buFont typeface="Arial" panose="020B0604020202020204" pitchFamily="34" charset="0"/>
-              <a:buChar char="•"/>
-            </a:pPr>
-            <a:r>
-              <a:rPr lang="fr-FR" sz="1400" dirty="0"/>
-              <a:t>Services à la demande sans gestion directe de l'infrastructure </a:t>
-            </a:r>
-            <a:r>
-              <a:rPr lang="fr-FR" sz="1400" dirty="0" smtClean="0"/>
-              <a:t>physique </a:t>
-            </a:r>
-            <a:endParaRPr lang="fr-FR" dirty="0"/>
+              <a:rPr lang="en-US" sz="1400" dirty="0"/>
+              <a:t>Set of computing resources (processing, storage, network) accessible remotely via the Internet</a:t>
+            </a:r>
+            <a:r>
+              <a:rPr lang="en-US" sz="1400" dirty="0"/>
+              <a:t/>
+            </a:r>
+            <a:br>
+              <a:rPr lang="en-US" sz="1400" dirty="0"/>
+            </a:br>
+            <a:r>
+              <a:rPr lang="en-US" sz="1400" dirty="0"/>
+              <a:t>On-demand services without direct management of the physical infrastructure</a:t>
+            </a:r>
+            <a:endParaRPr lang="fr-FR" sz="1400" dirty="0"/>
           </a:p>
         </p:txBody>
       </p:sp>
@@ -15610,7 +16759,7 @@
           <p:nvPr/>
         </p:nvPicPr>
         <p:blipFill>
-          <a:blip r:embed="rId2" cstate="print">
+          <a:blip r:embed="rId3" cstate="print">
             <a:extLst>
               <a:ext uri="{28A0092B-C50C-407E-A947-70E740481C1C}">
                 <a14:useLocalDpi xmlns:a14="http://schemas.microsoft.com/office/drawing/2010/main" val="0"/>
@@ -15659,16 +16808,12 @@
               </a:lnSpc>
             </a:pPr>
             <a:r>
+              <a:rPr lang="fr-FR" sz="1600" dirty="0" err="1" smtClean="0"/>
+              <a:t>Different</a:t>
+            </a:r>
+            <a:r>
               <a:rPr lang="fr-FR" sz="1600" dirty="0" smtClean="0"/>
-              <a:t>Les différents type de </a:t>
-            </a:r>
-            <a:r>
-              <a:rPr lang="fr-FR" sz="1600" dirty="0" err="1" smtClean="0"/>
-              <a:t>clouds</a:t>
-            </a:r>
-            <a:r>
-              <a:rPr lang="fr-FR" sz="1600" dirty="0" smtClean="0"/>
-              <a:t> :</a:t>
+              <a:t> cloud types :</a:t>
             </a:r>
             <a:endParaRPr lang="fr-FR" sz="2000" dirty="0" smtClean="0"/>
           </a:p>
@@ -15682,8 +16827,13 @@
             </a:pPr>
             <a:r>
               <a:rPr lang="fr-FR" sz="1400" dirty="0" smtClean="0"/>
-              <a:t>Cloud publics</a:t>
-            </a:r>
+              <a:t>Public </a:t>
+            </a:r>
+            <a:r>
+              <a:rPr lang="fr-FR" sz="1400" dirty="0" err="1" smtClean="0"/>
+              <a:t>clouds</a:t>
+            </a:r>
+            <a:endParaRPr lang="fr-FR" sz="1400" dirty="0" smtClean="0"/>
           </a:p>
           <a:p>
             <a:pPr marL="285750" indent="-285750">
@@ -15694,13 +16844,18 @@
               <a:buChar char="•"/>
             </a:pPr>
             <a:r>
-              <a:rPr lang="fr-FR" sz="1400" dirty="0"/>
-              <a:t>Cloud </a:t>
+              <a:rPr lang="fr-FR" sz="1400" dirty="0" err="1" smtClean="0"/>
+              <a:t>Private</a:t>
             </a:r>
             <a:r>
               <a:rPr lang="fr-FR" sz="1400" dirty="0" smtClean="0"/>
-              <a:t>privés</a:t>
-            </a:r>
+              <a:t> </a:t>
+            </a:r>
+            <a:r>
+              <a:rPr lang="fr-FR" sz="1400" dirty="0" err="1" smtClean="0"/>
+              <a:t>clouds</a:t>
+            </a:r>
+            <a:endParaRPr lang="fr-FR" sz="1400" dirty="0" smtClean="0"/>
           </a:p>
           <a:p>
             <a:pPr marL="285750" indent="-285750">
@@ -15711,8 +16866,16 @@
               <a:buChar char="•"/>
             </a:pPr>
             <a:r>
+              <a:rPr lang="fr-FR" sz="1400" dirty="0" err="1" smtClean="0"/>
+              <a:t>Hybrid</a:t>
+            </a:r>
+            <a:r>
               <a:rPr lang="fr-FR" sz="1400" dirty="0" smtClean="0"/>
-              <a:t>Cloud hybrides</a:t>
+              <a:t> </a:t>
+            </a:r>
+            <a:r>
+              <a:rPr lang="fr-FR" sz="1400" dirty="0" err="1" smtClean="0"/>
+              <a:t>clouds</a:t>
             </a:r>
             <a:endParaRPr lang="fr-FR" sz="1400" dirty="0"/>
           </a:p>
@@ -15727,7 +16890,7 @@
           <p:nvPr/>
         </p:nvPicPr>
         <p:blipFill>
-          <a:blip r:embed="rId3"/>
+          <a:blip r:embed="rId4"/>
           <a:stretch>
             <a:fillRect/>
           </a:stretch>
@@ -15742,6 +16905,86 @@
           </a:prstGeom>
         </p:spPr>
       </p:pic>
+      <p:sp>
+        <p:nvSpPr>
+          <p:cNvPr id="6" name="ZoneTexte 5"/>
+          <p:cNvSpPr txBox="1"/>
+          <p:nvPr/>
+        </p:nvSpPr>
+        <p:spPr>
+          <a:xfrm>
+            <a:off x="9932065" y="6427262"/>
+            <a:ext cx="1691360" cy="307777"/>
+          </a:xfrm>
+          <a:prstGeom prst="rect">
+            <a:avLst/>
+          </a:prstGeom>
+          <a:noFill/>
+        </p:spPr>
+        <p:txBody>
+          <a:bodyPr wrap="none" rtlCol="0">
+            <a:spAutoFit/>
+          </a:bodyPr>
+          <a:lstStyle/>
+          <a:p>
+            <a:r>
+              <a:rPr lang="fr-FR" sz="1400" dirty="0" smtClean="0"/>
+              <a:t>* Sources : </a:t>
+            </a:r>
+            <a:r>
+              <a:rPr lang="fr-FR" sz="1400" dirty="0" err="1" smtClean="0">
+                <a:hlinkClick r:id="rId5"/>
+              </a:rPr>
+              <a:t>Statista</a:t>
+            </a:r>
+            <a:r>
+              <a:rPr lang="fr-FR" sz="1400" dirty="0" smtClean="0"/>
+              <a:t> </a:t>
+            </a:r>
+            <a:endParaRPr lang="fr-FR" sz="1400" dirty="0"/>
+          </a:p>
+        </p:txBody>
+      </p:sp>
+      <p:sp>
+        <p:nvSpPr>
+          <p:cNvPr id="14" name="Espace réservé du pied de page 4"/>
+          <p:cNvSpPr>
+            <a:spLocks noGrp="1"/>
+          </p:cNvSpPr>
+          <p:nvPr>
+            <p:ph type="ftr" sz="quarter" idx="3"/>
+          </p:nvPr>
+        </p:nvSpPr>
+        <p:spPr>
+          <a:xfrm>
+            <a:off x="194408" y="6435303"/>
+            <a:ext cx="5672016" cy="365125"/>
+          </a:xfrm>
+        </p:spPr>
+        <p:txBody>
+          <a:bodyPr/>
+          <a:lstStyle/>
+          <a:p>
+            <a:r>
+              <a:rPr lang="en-US" dirty="0" smtClean="0"/>
+              <a:t>2025 </a:t>
+            </a:r>
+            <a:r>
+              <a:rPr lang="en-US" dirty="0" smtClean="0"/>
+              <a:t>| ©</a:t>
+            </a:r>
+            <a:r>
+              <a:rPr lang="en-US" dirty="0" err="1" smtClean="0"/>
+              <a:t>HeadMind</a:t>
+            </a:r>
+            <a:r>
+              <a:rPr lang="en-US" dirty="0" smtClean="0"/>
+              <a:t> Partners</a:t>
+            </a:r>
+            <a:endParaRPr lang="fr-FR" dirty="0"/>
+          </a:p>
+        </p:txBody>
+      </p:sp>
     </p:spTree>
     <p:extLst>
       <p:ext uri="{BB962C8B-B14F-4D97-AF65-F5344CB8AC3E}">
@@ -15788,8 +17031,8 @@
           <a:lstStyle/>
           <a:p>
             <a:r>
-              <a:rPr lang="fr-FR" dirty="0" smtClean="0"/>
-              <a:t>Introduction et objectifs</a:t>
+              <a:rPr lang="fr-FR" dirty="0"/>
+              <a:t>Introduction &amp; objectives</a:t>
             </a:r>
             <a:endParaRPr lang="fr-FR" dirty="0"/>
           </a:p>
@@ -15820,29 +17063,6 @@
               </a:pPr>
               <a:t>6</a:t>
             </a:fld>
-            <a:endParaRPr lang="fr-FR" dirty="0"/>
-          </a:p>
-        </p:txBody>
-      </p:sp>
-      <p:sp>
-        <p:nvSpPr>
-          <p:cNvPr id="5" name="Espace réservé du pied de page 4"/>
-          <p:cNvSpPr>
-            <a:spLocks noGrp="1"/>
-          </p:cNvSpPr>
-          <p:nvPr>
-            <p:ph type="ftr" sz="quarter" idx="3"/>
-          </p:nvPr>
-        </p:nvSpPr>
-        <p:spPr/>
-        <p:txBody>
-          <a:bodyPr/>
-          <a:lstStyle/>
-          <a:p>
-            <a:r>
-              <a:rPr lang="en-US" smtClean="0"/>
-              <a:t>2024 | ©HeadMind Partners</a:t>
-            </a:r>
             <a:endParaRPr lang="fr-FR" dirty="0"/>
           </a:p>
         </p:txBody>
@@ -15880,7 +17100,7 @@
         <p:spPr>
           <a:xfrm>
             <a:off x="724073" y="1172324"/>
-            <a:ext cx="6267797" cy="5262979"/>
+            <a:ext cx="6267797" cy="3539430"/>
           </a:xfrm>
           <a:prstGeom prst="rect">
             <a:avLst/>
@@ -15899,9 +17119,38 @@
               </a:lnSpc>
             </a:pPr>
             <a:r>
+              <a:rPr lang="fr-FR" sz="1600" dirty="0" err="1" smtClean="0"/>
+              <a:t>Why</a:t>
+            </a:r>
+            <a:r>
               <a:rPr lang="fr-FR" sz="1600" dirty="0" smtClean="0"/>
-              <a:t>Pourquoi utiliser un cloud pour réaliser les tâches de la séance ? </a:t>
-            </a:r>
+              <a:t> </a:t>
+            </a:r>
+            <a:r>
+              <a:rPr lang="fr-FR" sz="1600" dirty="0" err="1" smtClean="0"/>
+              <a:t>should</a:t>
+            </a:r>
+            <a:r>
+              <a:rPr lang="fr-FR" sz="1600" dirty="0" smtClean="0"/>
+              <a:t> </a:t>
+            </a:r>
+            <a:r>
+              <a:rPr lang="fr-FR" sz="1600" dirty="0" err="1" smtClean="0"/>
+              <a:t>we</a:t>
+            </a:r>
+            <a:r>
+              <a:rPr lang="fr-FR" sz="1600" dirty="0" smtClean="0"/>
+              <a:t> use a cloud for </a:t>
+            </a:r>
+            <a:r>
+              <a:rPr lang="fr-FR" sz="1600" dirty="0" err="1" smtClean="0"/>
+              <a:t>today’s</a:t>
+            </a:r>
+            <a:r>
+              <a:rPr lang="fr-FR" sz="1600" dirty="0" smtClean="0"/>
+              <a:t> session ?</a:t>
+            </a:r>
+            <a:endParaRPr lang="fr-FR" sz="1600" dirty="0" smtClean="0"/>
           </a:p>
           <a:p>
             <a:pPr>
@@ -15910,182 +17159,329 @@
               </a:lnSpc>
             </a:pPr>
             <a:r>
-              <a:rPr lang="fr-FR" sz="1400" b="1" dirty="0" smtClean="0"/>
+              <a:rPr lang="fr-FR" sz="1600" b="1" dirty="0" smtClean="0"/>
               <a:t>Azure Machine Learning</a:t>
             </a:r>
-            <a:endParaRPr lang="fr-FR" sz="1400" b="1" dirty="0"/>
-          </a:p>
-          <a:p>
-            <a:pPr>
-              <a:lnSpc>
-                <a:spcPct val="150000"/>
-              </a:lnSpc>
-            </a:pPr>
-            <a:r>
-              <a:rPr lang="fr-FR" sz="1400" dirty="0" smtClean="0"/>
-              <a:t>Pour l’entraînement de modèles :</a:t>
-            </a:r>
+            <a:endParaRPr lang="fr-FR" sz="1600" b="1" dirty="0"/>
           </a:p>
           <a:p>
             <a:pPr marL="285750" indent="-285750">
-              <a:lnSpc>
-                <a:spcPct val="150000"/>
-              </a:lnSpc>
               <a:buFont typeface="Arial" panose="020B0604020202020204" pitchFamily="34" charset="0"/>
               <a:buChar char="•"/>
             </a:pPr>
             <a:r>
-              <a:rPr lang="fr-FR" sz="1400" dirty="0" smtClean="0"/>
-              <a:t>Accès à de la puissance de calcul (CPU/GPU), entraînement possiblement long</a:t>
-            </a:r>
-          </a:p>
-          <a:p>
-            <a:pPr marL="285750" indent="-285750">
-              <a:lnSpc>
-                <a:spcPct val="150000"/>
-              </a:lnSpc>
+              <a:rPr lang="fr-FR" sz="1600" dirty="0"/>
+              <a:t>For model </a:t>
+            </a:r>
+            <a:r>
+              <a:rPr lang="fr-FR" sz="1600" dirty="0" smtClean="0"/>
+              <a:t>training:</a:t>
+            </a:r>
+          </a:p>
+          <a:p>
+            <a:pPr marL="742950" lvl="1" indent="-285750">
               <a:buFont typeface="Arial" panose="020B0604020202020204" pitchFamily="34" charset="0"/>
               <a:buChar char="•"/>
             </a:pPr>
             <a:r>
-              <a:rPr lang="fr-FR" sz="1400" dirty="0" err="1" smtClean="0"/>
-              <a:t>Scalabilité</a:t>
-            </a:r>
-            <a:r>
-              <a:rPr lang="fr-FR" sz="1400" dirty="0" smtClean="0"/>
-              <a:t> possible</a:t>
-            </a:r>
-          </a:p>
-          <a:p>
-            <a:pPr marL="285750" indent="-285750">
-              <a:lnSpc>
-                <a:spcPct val="150000"/>
-              </a:lnSpc>
+              <a:rPr lang="fr-FR" sz="1600" dirty="0" smtClean="0"/>
+              <a:t>Access </a:t>
+            </a:r>
+            <a:r>
+              <a:rPr lang="fr-FR" sz="1600" dirty="0"/>
+              <a:t>to </a:t>
+            </a:r>
+            <a:r>
+              <a:rPr lang="fr-FR" sz="1600" dirty="0" err="1"/>
+              <a:t>computing</a:t>
+            </a:r>
+            <a:r>
+              <a:rPr lang="fr-FR" sz="1600" dirty="0"/>
+              <a:t> power (CPU/GPU), </a:t>
+            </a:r>
+            <a:r>
+              <a:rPr lang="fr-FR" sz="1600" dirty="0" err="1"/>
+              <a:t>potentially</a:t>
+            </a:r>
+            <a:r>
+              <a:rPr lang="fr-FR" sz="1600" dirty="0"/>
+              <a:t> long training </a:t>
+            </a:r>
+            <a:r>
+              <a:rPr lang="fr-FR" sz="1600" dirty="0" smtClean="0"/>
+              <a:t>duration</a:t>
+            </a:r>
+          </a:p>
+          <a:p>
+            <a:pPr marL="742950" lvl="1" indent="-285750">
               <a:buFont typeface="Arial" panose="020B0604020202020204" pitchFamily="34" charset="0"/>
               <a:buChar char="•"/>
             </a:pPr>
-            <a:endParaRPr lang="fr-FR" sz="1400" dirty="0"/>
-          </a:p>
-          <a:p>
-            <a:pPr>
-              <a:lnSpc>
-                <a:spcPct val="150000"/>
-              </a:lnSpc>
-            </a:pPr>
-            <a:r>
-              <a:rPr lang="fr-FR" sz="1400" dirty="0"/>
-              <a:t>Optimiser les </a:t>
-            </a:r>
-            <a:r>
-              <a:rPr lang="fr-FR" sz="1400" dirty="0" err="1"/>
-              <a:t>hyperparamètres</a:t>
-            </a:r>
-            <a:r>
-              <a:rPr lang="fr-FR" sz="1400" b="1" dirty="0"/>
-              <a:t> </a:t>
-            </a:r>
-            <a:r>
-              <a:rPr lang="fr-FR" sz="1400" dirty="0" smtClean="0"/>
-              <a:t>d’entraînements:</a:t>
-            </a:r>
+            <a:r>
+              <a:rPr lang="fr-FR" sz="1600" dirty="0" err="1" smtClean="0"/>
+              <a:t>Scaling</a:t>
+            </a:r>
+            <a:r>
+              <a:rPr lang="fr-FR" sz="1600" dirty="0" smtClean="0"/>
+              <a:t> up ressources </a:t>
+            </a:r>
+            <a:r>
+              <a:rPr lang="fr-FR" sz="1600" dirty="0" err="1" smtClean="0"/>
+              <a:t>is</a:t>
+            </a:r>
+            <a:r>
+              <a:rPr lang="fr-FR" sz="1600" dirty="0" smtClean="0"/>
+              <a:t> </a:t>
+            </a:r>
+            <a:r>
+              <a:rPr lang="fr-FR" sz="1600" dirty="0" err="1" smtClean="0"/>
+              <a:t>easy</a:t>
+            </a:r>
+            <a:r>
+              <a:rPr lang="fr-FR" sz="1600" dirty="0" smtClean="0"/>
+              <a:t> for </a:t>
+            </a:r>
+            <a:r>
+              <a:rPr lang="fr-FR" sz="1600" dirty="0" err="1" smtClean="0"/>
+              <a:t>tougher</a:t>
+            </a:r>
+            <a:r>
+              <a:rPr lang="fr-FR" sz="1600" dirty="0" smtClean="0"/>
+              <a:t> </a:t>
+            </a:r>
+            <a:r>
+              <a:rPr lang="fr-FR" sz="1600" dirty="0" err="1" smtClean="0"/>
+              <a:t>workloads</a:t>
+            </a:r>
+            <a:endParaRPr lang="fr-FR" sz="1600" dirty="0"/>
           </a:p>
           <a:p>
             <a:pPr marL="285750" indent="-285750">
-              <a:lnSpc>
-                <a:spcPct val="150000"/>
-              </a:lnSpc>
               <a:buFont typeface="Arial" panose="020B0604020202020204" pitchFamily="34" charset="0"/>
               <a:buChar char="•"/>
             </a:pPr>
             <a:r>
-              <a:rPr lang="fr-FR" sz="1400" dirty="0" smtClean="0"/>
-              <a:t>Lancement de plusieurs entraînements avec différents paramètres en parallèle</a:t>
-            </a:r>
-          </a:p>
-          <a:p>
-            <a:pPr marL="285750" indent="-285750">
-              <a:lnSpc>
-                <a:spcPct val="150000"/>
-              </a:lnSpc>
+              <a:rPr lang="fr-FR" sz="1600" dirty="0" err="1"/>
+              <a:t>Optimize</a:t>
+            </a:r>
+            <a:r>
+              <a:rPr lang="fr-FR" sz="1600" dirty="0"/>
+              <a:t> training </a:t>
+            </a:r>
+            <a:r>
+              <a:rPr lang="fr-FR" sz="1600" dirty="0" err="1" smtClean="0"/>
+              <a:t>hyperparameters</a:t>
+            </a:r>
+            <a:endParaRPr lang="fr-FR" sz="1600" dirty="0" smtClean="0"/>
+          </a:p>
+          <a:p>
+            <a:pPr marL="742950" lvl="1" indent="-285750">
               <a:buFont typeface="Arial" panose="020B0604020202020204" pitchFamily="34" charset="0"/>
               <a:buChar char="•"/>
             </a:pPr>
             <a:r>
-              <a:rPr lang="fr-FR" sz="1400" dirty="0" smtClean="0"/>
-              <a:t>Outils directement intégrés</a:t>
-            </a:r>
-            <a:endParaRPr lang="fr-FR" sz="1400" dirty="0"/>
-          </a:p>
-          <a:p>
-            <a:pPr marL="285750" indent="-285750">
-              <a:lnSpc>
-                <a:spcPct val="150000"/>
-              </a:lnSpc>
+              <a:rPr lang="fr-FR" sz="1600" dirty="0" err="1" smtClean="0"/>
+              <a:t>Parallel</a:t>
+            </a:r>
+            <a:r>
+              <a:rPr lang="fr-FR" sz="1600" dirty="0" smtClean="0"/>
+              <a:t> </a:t>
+            </a:r>
+            <a:r>
+              <a:rPr lang="fr-FR" sz="1600" dirty="0" err="1" smtClean="0"/>
+              <a:t>launch</a:t>
+            </a:r>
+            <a:r>
+              <a:rPr lang="fr-FR" sz="1600" dirty="0" smtClean="0"/>
+              <a:t> of multiple </a:t>
+            </a:r>
+            <a:r>
+              <a:rPr lang="fr-FR" sz="1600" dirty="0"/>
+              <a:t>trainings </a:t>
+            </a:r>
+            <a:r>
+              <a:rPr lang="fr-FR" sz="1600" dirty="0" err="1"/>
+              <a:t>with</a:t>
+            </a:r>
+            <a:r>
+              <a:rPr lang="fr-FR" sz="1600" dirty="0"/>
+              <a:t> </a:t>
+            </a:r>
+            <a:r>
+              <a:rPr lang="fr-FR" sz="1600" dirty="0" err="1"/>
+              <a:t>different</a:t>
+            </a:r>
+            <a:r>
+              <a:rPr lang="fr-FR" sz="1600" dirty="0"/>
+              <a:t> </a:t>
+            </a:r>
+            <a:r>
+              <a:rPr lang="fr-FR" sz="1600" dirty="0" err="1"/>
+              <a:t>parameters</a:t>
+            </a:r>
+            <a:r>
+              <a:rPr lang="fr-FR" sz="1600" dirty="0"/>
+              <a:t> in </a:t>
+            </a:r>
+            <a:r>
+              <a:rPr lang="fr-FR" sz="1600" dirty="0" smtClean="0"/>
+              <a:t>Integrated </a:t>
+            </a:r>
+            <a:r>
+              <a:rPr lang="fr-FR" sz="1600" dirty="0" err="1" smtClean="0"/>
+              <a:t>tools</a:t>
+            </a:r>
+            <a:endParaRPr lang="fr-FR" sz="1600" dirty="0"/>
+          </a:p>
+          <a:p>
+            <a:pPr marL="742950" lvl="1" indent="-285750">
               <a:buFont typeface="Arial" panose="020B0604020202020204" pitchFamily="34" charset="0"/>
               <a:buChar char="•"/>
             </a:pPr>
             <a:r>
-              <a:rPr lang="fr-FR" sz="1400" dirty="0" smtClean="0"/>
-              <a:t>Coût réduit pour les entraînements non prometteurs</a:t>
-            </a:r>
-          </a:p>
-          <a:p>
-            <a:pPr>
-              <a:lnSpc>
-                <a:spcPct val="150000"/>
-              </a:lnSpc>
-            </a:pPr>
-            <a:endParaRPr lang="fr-FR" sz="1200" dirty="0" smtClean="0"/>
-          </a:p>
-          <a:p>
-            <a:pPr>
-              <a:lnSpc>
-                <a:spcPct val="150000"/>
-              </a:lnSpc>
-            </a:pPr>
-            <a:r>
-              <a:rPr lang="fr-FR" sz="1400" dirty="0" smtClean="0"/>
-              <a:t>Déploiement de modèles:</a:t>
+              <a:rPr lang="fr-FR" sz="1600" dirty="0" err="1" smtClean="0"/>
+              <a:t>Reduced</a:t>
+            </a:r>
+            <a:r>
+              <a:rPr lang="fr-FR" sz="1600" dirty="0" smtClean="0"/>
+              <a:t> </a:t>
+            </a:r>
+            <a:r>
+              <a:rPr lang="fr-FR" sz="1600" dirty="0" err="1"/>
+              <a:t>cost</a:t>
+            </a:r>
+            <a:r>
+              <a:rPr lang="fr-FR" sz="1600" dirty="0"/>
+              <a:t> for </a:t>
+            </a:r>
+            <a:r>
+              <a:rPr lang="fr-FR" sz="1600" dirty="0" err="1"/>
+              <a:t>unpromising</a:t>
+            </a:r>
+            <a:r>
+              <a:rPr lang="fr-FR" sz="1600" dirty="0"/>
+              <a:t> trainings</a:t>
             </a:r>
           </a:p>
           <a:p>
             <a:pPr marL="285750" indent="-285750">
-              <a:lnSpc>
-                <a:spcPct val="150000"/>
-              </a:lnSpc>
               <a:buFont typeface="Arial" panose="020B0604020202020204" pitchFamily="34" charset="0"/>
               <a:buChar char="•"/>
             </a:pPr>
             <a:r>
-              <a:rPr lang="fr-FR" sz="1400" dirty="0" smtClean="0"/>
-              <a:t>Azure Machine Learning met à disposition des « </a:t>
-            </a:r>
-            <a:r>
-              <a:rPr lang="fr-FR" sz="1400" dirty="0" err="1" smtClean="0"/>
-              <a:t>endpoints</a:t>
-            </a:r>
-            <a:r>
-              <a:rPr lang="fr-FR" sz="1400" dirty="0" smtClean="0"/>
-              <a:t> » managés</a:t>
-            </a:r>
-          </a:p>
-          <a:p>
-            <a:pPr marL="285750" indent="-285750">
-              <a:lnSpc>
-                <a:spcPct val="150000"/>
-              </a:lnSpc>
+              <a:rPr lang="fr-FR" sz="1600" dirty="0"/>
+              <a:t>Model </a:t>
+            </a:r>
+            <a:r>
+              <a:rPr lang="fr-FR" sz="1600" dirty="0" err="1" smtClean="0"/>
+              <a:t>deployment</a:t>
+            </a:r>
+            <a:r>
+              <a:rPr lang="fr-FR" sz="1600" dirty="0" smtClean="0"/>
+              <a:t>:</a:t>
+            </a:r>
+          </a:p>
+          <a:p>
+            <a:pPr marL="742950" lvl="1" indent="-285750">
               <a:buFont typeface="Arial" panose="020B0604020202020204" pitchFamily="34" charset="0"/>
               <a:buChar char="•"/>
             </a:pPr>
             <a:r>
-              <a:rPr lang="fr-FR" sz="1400" dirty="0" err="1" smtClean="0"/>
-              <a:t>Scalabilité</a:t>
-            </a:r>
-            <a:r>
-              <a:rPr lang="fr-FR" sz="1400" dirty="0" smtClean="0"/>
-              <a:t> possible</a:t>
-            </a:r>
-            <a:endParaRPr lang="fr-FR" sz="1400" dirty="0"/>
+              <a:rPr lang="fr-FR" sz="1600" dirty="0" smtClean="0"/>
+              <a:t>Azure </a:t>
+            </a:r>
+            <a:r>
+              <a:rPr lang="fr-FR" sz="1600" dirty="0"/>
+              <a:t>Machine Learning </a:t>
+            </a:r>
+            <a:r>
+              <a:rPr lang="fr-FR" sz="1600" dirty="0" err="1"/>
+              <a:t>provides</a:t>
+            </a:r>
+            <a:r>
+              <a:rPr lang="fr-FR" sz="1600" dirty="0"/>
+              <a:t> </a:t>
+            </a:r>
+            <a:r>
+              <a:rPr lang="fr-FR" sz="1600" dirty="0" err="1"/>
+              <a:t>managed</a:t>
+            </a:r>
+            <a:r>
+              <a:rPr lang="fr-FR" sz="1600" dirty="0"/>
+              <a:t> </a:t>
+            </a:r>
+            <a:r>
+              <a:rPr lang="fr-FR" sz="1600" dirty="0" err="1" smtClean="0"/>
+              <a:t>endpoints</a:t>
+            </a:r>
+            <a:endParaRPr lang="fr-FR" sz="1600" dirty="0"/>
+          </a:p>
+          <a:p>
+            <a:pPr marL="742950" lvl="1" indent="-285750">
+              <a:buFont typeface="Arial" panose="020B0604020202020204" pitchFamily="34" charset="0"/>
+              <a:buChar char="•"/>
+            </a:pPr>
+            <a:r>
+              <a:rPr lang="fr-FR" sz="1600" dirty="0" err="1" smtClean="0"/>
+              <a:t>Scalable</a:t>
+            </a:r>
+            <a:r>
+              <a:rPr lang="fr-FR" sz="1600" dirty="0" smtClean="0"/>
+              <a:t> </a:t>
+            </a:r>
+            <a:r>
+              <a:rPr lang="fr-FR" sz="1600" dirty="0" err="1" smtClean="0"/>
+              <a:t>endpoint</a:t>
+            </a:r>
+            <a:r>
+              <a:rPr lang="fr-FR" sz="1600" dirty="0" smtClean="0"/>
+              <a:t> for </a:t>
+            </a:r>
+            <a:r>
+              <a:rPr lang="fr-FR" sz="1600" dirty="0" err="1" smtClean="0"/>
+              <a:t>inference</a:t>
+            </a:r>
+            <a:endParaRPr lang="fr-FR" sz="1600" dirty="0"/>
+          </a:p>
+        </p:txBody>
+      </p:sp>
+      <p:sp>
+        <p:nvSpPr>
+          <p:cNvPr id="7" name="Espace réservé du pied de page 4"/>
+          <p:cNvSpPr>
+            <a:spLocks noGrp="1"/>
+          </p:cNvSpPr>
+          <p:nvPr>
+            <p:ph type="ftr" sz="quarter" idx="3"/>
+          </p:nvPr>
+        </p:nvSpPr>
+        <p:spPr>
+          <a:xfrm>
+            <a:off x="194408" y="6435303"/>
+            <a:ext cx="5672016" cy="365125"/>
+          </a:xfrm>
+        </p:spPr>
+        <p:txBody>
+          <a:bodyPr/>
+          <a:lstStyle/>
+          <a:p>
+            <a:r>
+              <a:rPr lang="en-US" dirty="0" smtClean="0"/>
+              <a:t>2025 </a:t>
+            </a:r>
+            <a:r>
+              <a:rPr lang="en-US" dirty="0" smtClean="0"/>
+              <a:t>| ©</a:t>
+            </a:r>
+            <a:r>
+              <a:rPr lang="en-US" dirty="0" err="1" smtClean="0"/>
+              <a:t>HeadMind</a:t>
+            </a:r>
+            <a:r>
+              <a:rPr lang="en-US" dirty="0" smtClean="0"/>
+              <a:t> Partners</a:t>
+            </a:r>
+            <a:endParaRPr lang="fr-FR" dirty="0"/>
           </a:p>
         </p:txBody>
       </p:sp>
@@ -16136,7 +17532,7 @@
           <a:p>
             <a:r>
               <a:rPr lang="fr-FR" dirty="0" smtClean="0"/>
-              <a:t>Entraînement du modèle</a:t>
+              <a:t>Model training</a:t>
             </a:r>
             <a:endParaRPr lang="fr-FR" dirty="0"/>
           </a:p>
@@ -16159,7 +17555,7 @@
           <a:p>
             <a:r>
               <a:rPr lang="fr-FR" dirty="0" smtClean="0"/>
-              <a:t>Données, démonstration sur Azure</a:t>
+              <a:t>Data, Azure hands-on</a:t>
             </a:r>
             <a:endParaRPr lang="fr-FR" dirty="0"/>
           </a:p>
@@ -16211,12 +17607,12 @@
           <a:lstStyle/>
           <a:p>
             <a:r>
+              <a:rPr lang="fr-FR" dirty="0" smtClean="0"/>
+              <a:t>Training </a:t>
+            </a:r>
+            <a:r>
               <a:rPr lang="fr-FR" dirty="0" err="1" smtClean="0"/>
-              <a:t>Dataset</a:t>
-            </a:r>
-            <a:r>
-              <a:rPr lang="fr-FR" dirty="0" smtClean="0"/>
-              <a:t> d’entraînement</a:t>
+              <a:t>dataset</a:t>
             </a:r>
             <a:endParaRPr lang="fr-FR" dirty="0"/>
           </a:p>
@@ -16247,29 +17643,6 @@
               </a:pPr>
               <a:t>8</a:t>
             </a:fld>
-            <a:endParaRPr lang="fr-FR" dirty="0"/>
-          </a:p>
-        </p:txBody>
-      </p:sp>
-      <p:sp>
-        <p:nvSpPr>
-          <p:cNvPr id="5" name="Espace réservé du pied de page 4"/>
-          <p:cNvSpPr>
-            <a:spLocks noGrp="1"/>
-          </p:cNvSpPr>
-          <p:nvPr>
-            <p:ph type="ftr" sz="quarter" idx="3"/>
-          </p:nvPr>
-        </p:nvSpPr>
-        <p:spPr/>
-        <p:txBody>
-          <a:bodyPr/>
-          <a:lstStyle/>
-          <a:p>
-            <a:r>
-              <a:rPr lang="en-US" smtClean="0"/>
-              <a:t>2024 | ©HeadMind Partners</a:t>
-            </a:r>
             <a:endParaRPr lang="fr-FR" dirty="0"/>
           </a:p>
         </p:txBody>
@@ -16322,9 +17695,22 @@
               <a:buNone/>
             </a:pPr>
             <a:r>
+              <a:rPr lang="fr-FR" dirty="0" err="1" smtClean="0"/>
+              <a:t>What</a:t>
+            </a:r>
+            <a:r>
               <a:rPr lang="fr-FR" dirty="0" smtClean="0"/>
-              <a:t>Qu’est ce que MNIST :</a:t>
-            </a:r>
+              <a:t> </a:t>
+            </a:r>
+            <a:r>
+              <a:rPr lang="fr-FR" dirty="0" err="1" smtClean="0"/>
+              <a:t>is</a:t>
+            </a:r>
+            <a:r>
+              <a:rPr lang="fr-FR" dirty="0" smtClean="0"/>
+              <a:t> MNIST ?</a:t>
+            </a:r>
+            <a:endParaRPr lang="fr-FR" dirty="0" smtClean="0"/>
           </a:p>
           <a:p>
             <a:r>
@@ -16375,56 +17761,49 @@
           <a:p>
             <a:r>
               <a:rPr lang="en-US" dirty="0" smtClean="0"/>
-              <a:t>70 000 images de digits </a:t>
+              <a:t>70 000 </a:t>
+            </a:r>
+            <a:r>
+              <a:rPr lang="en-US" dirty="0" smtClean="0"/>
+              <a:t>digit greyscale images</a:t>
+            </a:r>
+            <a:endParaRPr lang="en-US" dirty="0" smtClean="0"/>
+          </a:p>
+          <a:p>
+            <a:r>
+              <a:rPr lang="en-US" dirty="0" smtClean="0"/>
+              <a:t>60 000 </a:t>
+            </a:r>
+            <a:r>
+              <a:rPr lang="en-US" dirty="0" smtClean="0"/>
+              <a:t>training images &amp; </a:t>
+            </a:r>
+            <a:r>
+              <a:rPr lang="en-US" dirty="0" smtClean="0"/>
+              <a:t>10 </a:t>
+            </a:r>
+            <a:r>
+              <a:rPr lang="en-US" dirty="0" smtClean="0"/>
+              <a:t>000 images in the test set</a:t>
+            </a:r>
+            <a:endParaRPr lang="en-US" dirty="0" smtClean="0"/>
+          </a:p>
+          <a:p>
+            <a:r>
+              <a:rPr lang="en-US" dirty="0" smtClean="0"/>
+              <a:t>Created by </a:t>
+            </a:r>
+            <a:r>
+              <a:rPr lang="en-US" dirty="0" smtClean="0"/>
+              <a:t>Yan </a:t>
             </a:r>
             <a:r>
               <a:rPr lang="en-US" dirty="0" err="1" smtClean="0"/>
-              <a:t>en</a:t>
+              <a:t>LeCun</a:t>
             </a:r>
             <a:r>
               <a:rPr lang="en-US" dirty="0" smtClean="0"/>
               <a:t> </a:t>
-            </a:r>
-            <a:r>
-              <a:rPr lang="en-US" dirty="0" err="1" smtClean="0"/>
-              <a:t>niveau</a:t>
-            </a:r>
-            <a:r>
-              <a:rPr lang="en-US" dirty="0" smtClean="0"/>
-              <a:t> de </a:t>
-            </a:r>
-            <a:r>
-              <a:rPr lang="en-US" dirty="0" err="1" smtClean="0"/>
-              <a:t>gris</a:t>
-            </a:r>
-            <a:endParaRPr lang="en-US" dirty="0" smtClean="0"/>
-          </a:p>
-          <a:p>
-            <a:r>
-              <a:rPr lang="en-US" dirty="0" smtClean="0"/>
-              <a:t>60 000 images </a:t>
-            </a:r>
-            <a:r>
-              <a:rPr lang="en-US" dirty="0" err="1" smtClean="0"/>
-              <a:t>d’entraînement</a:t>
-            </a:r>
-            <a:r>
-              <a:rPr lang="en-US" dirty="0" smtClean="0"/>
-              <a:t> et 10 000 images de test</a:t>
-            </a:r>
-          </a:p>
-          <a:p>
-            <a:r>
-              <a:rPr lang="en-US" dirty="0" err="1" smtClean="0"/>
-              <a:t>Créé</a:t>
-            </a:r>
-            <a:r>
-              <a:rPr lang="en-US" dirty="0" smtClean="0"/>
-              <a:t> par Yan </a:t>
-            </a:r>
-            <a:r>
-              <a:rPr lang="en-US" dirty="0" err="1" smtClean="0"/>
-              <a:t>LeCun</a:t>
             </a:r>
             <a:endParaRPr lang="en-US" dirty="0" smtClean="0"/>
           </a:p>
@@ -16439,8 +17818,20 @@
               <a:buNone/>
             </a:pPr>
             <a:r>
+              <a:rPr lang="fr-FR" dirty="0" err="1" smtClean="0"/>
+              <a:t>Why</a:t>
+            </a:r>
+            <a:r>
               <a:rPr lang="fr-FR" dirty="0" smtClean="0"/>
-              <a:t>Pourquoi ce </a:t>
+              <a:t> </a:t>
+            </a:r>
+            <a:r>
+              <a:rPr lang="fr-FR" dirty="0" err="1" smtClean="0"/>
+              <a:t>this</a:t>
+            </a:r>
+            <a:r>
+              <a:rPr lang="fr-FR" dirty="0" smtClean="0"/>
+              <a:t> </a:t>
             </a:r>
             <a:r>
               <a:rPr lang="fr-FR" dirty="0" err="1" smtClean="0"/>
@@ -16450,27 +17841,58 @@
               <a:rPr lang="fr-FR" dirty="0" smtClean="0"/>
               <a:t> ?</a:t>
             </a:r>
+            <a:endParaRPr lang="fr-FR" dirty="0" smtClean="0"/>
           </a:p>
           <a:p>
             <a:r>
               <a:rPr lang="fr-FR" dirty="0" err="1" smtClean="0"/>
-              <a:t>Dataset</a:t>
+              <a:t>Staple</a:t>
             </a:r>
             <a:r>
               <a:rPr lang="fr-FR" dirty="0" smtClean="0"/>
-              <a:t> de référence pour les algorithmes de ML</a:t>
-            </a:r>
-          </a:p>
-          <a:p>
+              <a:t> </a:t>
+            </a:r>
+            <a:r>
+              <a:rPr lang="fr-FR" dirty="0" err="1" smtClean="0"/>
+              <a:t>dataset</a:t>
+            </a:r>
             <a:r>
               <a:rPr lang="fr-FR" dirty="0" smtClean="0"/>
-              <a:t>Peu complexe</a:t>
-            </a:r>
+              <a:t> for ML </a:t>
+            </a:r>
+            <a:r>
+              <a:rPr lang="fr-FR" dirty="0" err="1" smtClean="0"/>
+              <a:t>algorithms</a:t>
+            </a:r>
+            <a:endParaRPr lang="fr-FR" dirty="0" smtClean="0"/>
           </a:p>
           <a:p>
             <a:r>
               <a:rPr lang="fr-FR" dirty="0" smtClean="0"/>
-              <a:t>Idéal pour l’initiation</a:t>
+              <a:t>Simple</a:t>
+            </a:r>
+            <a:endParaRPr lang="fr-FR" dirty="0" smtClean="0"/>
+          </a:p>
+          <a:p>
+            <a:r>
+              <a:rPr lang="fr-FR" dirty="0" err="1" smtClean="0"/>
+              <a:t>Ideal</a:t>
+            </a:r>
+            <a:r>
+              <a:rPr lang="fr-FR" dirty="0" smtClean="0"/>
+              <a:t> for </a:t>
+            </a:r>
+            <a:r>
+              <a:rPr lang="fr-FR" dirty="0" err="1" smtClean="0"/>
+              <a:t>discovering</a:t>
+            </a:r>
+            <a:r>
+              <a:rPr lang="fr-FR" dirty="0" smtClean="0"/>
+              <a:t> </a:t>
+            </a:r>
+            <a:r>
+              <a:rPr lang="fr-FR" dirty="0" err="1" smtClean="0"/>
+              <a:t>purposes</a:t>
             </a:r>
             <a:endParaRPr lang="fr-FR" dirty="0"/>
           </a:p>
@@ -16491,7 +17913,7 @@
         </p:blipFill>
         <p:spPr>
           <a:xfrm>
-            <a:off x="8782050" y="2868413"/>
+            <a:off x="8782050" y="2883810"/>
             <a:ext cx="2757487" cy="1628775"/>
           </a:xfrm>
           <a:prstGeom prst="rect">
@@ -16549,6 +17971,46 @@
             <a:r>
               <a:rPr lang="fr-FR" sz="1400" dirty="0" smtClean="0"/>
               <a:t> 3</a:t>
+            </a:r>
+            <a:endParaRPr lang="fr-FR" dirty="0"/>
+          </a:p>
+        </p:txBody>
+      </p:sp>
+      <p:sp>
+        <p:nvSpPr>
+          <p:cNvPr id="15" name="Espace réservé du pied de page 4"/>
+          <p:cNvSpPr>
+            <a:spLocks noGrp="1"/>
+          </p:cNvSpPr>
+          <p:nvPr>
+            <p:ph type="ftr" sz="quarter" idx="3"/>
+          </p:nvPr>
+        </p:nvSpPr>
+        <p:spPr>
+          <a:xfrm>
+            <a:off x="194408" y="6435303"/>
+            <a:ext cx="5672016" cy="365125"/>
+          </a:xfrm>
+        </p:spPr>
+        <p:txBody>
+          <a:bodyPr/>
+          <a:lstStyle/>
+          <a:p>
+            <a:r>
+              <a:rPr lang="en-US" dirty="0" smtClean="0"/>
+              <a:t>2025 </a:t>
+            </a:r>
+            <a:r>
+              <a:rPr lang="en-US" dirty="0" smtClean="0"/>
+              <a:t>| ©</a:t>
+            </a:r>
+            <a:r>
+              <a:rPr lang="en-US" dirty="0" err="1" smtClean="0"/>
+              <a:t>HeadMind</a:t>
+            </a:r>
+            <a:r>
+              <a:rPr lang="en-US" dirty="0" smtClean="0"/>
+              <a:t> Partners</a:t>
             </a:r>
             <a:endParaRPr lang="fr-FR" dirty="0"/>
           </a:p>
@@ -16601,7 +18063,7 @@
           <a:p>
             <a:r>
               <a:rPr lang="fr-FR" dirty="0" smtClean="0"/>
-              <a:t>Entraînement du modèle</a:t>
+              <a:t>Model training</a:t>
             </a:r>
             <a:endParaRPr lang="fr-FR" dirty="0"/>
           </a:p>
@@ -16652,8 +18114,20 @@
           <a:lstStyle/>
           <a:p>
             <a:r>
-              <a:rPr lang="en-US" smtClean="0"/>
-              <a:t>2024 | ©HeadMind Partners</a:t>
+              <a:rPr lang="en-US" dirty="0" smtClean="0"/>
+              <a:t>2025 </a:t>
+            </a:r>
+            <a:r>
+              <a:rPr lang="en-US" dirty="0" smtClean="0"/>
+              <a:t>| ©</a:t>
+            </a:r>
+            <a:r>
+              <a:rPr lang="en-US" dirty="0" err="1" smtClean="0"/>
+              <a:t>HeadMind</a:t>
+            </a:r>
+            <a:r>
+              <a:rPr lang="en-US" dirty="0" smtClean="0"/>
+              <a:t> Partners</a:t>
             </a:r>
             <a:endParaRPr lang="fr-FR" dirty="0"/>
           </a:p>
@@ -16672,7 +18146,7 @@
         <p:spPr>
           <a:xfrm>
             <a:off x="5202604" y="4894268"/>
-            <a:ext cx="1771650" cy="1049137"/>
+            <a:ext cx="2547602" cy="1049137"/>
           </a:xfrm>
         </p:spPr>
         <p:txBody>
@@ -16684,7 +18158,27 @@
             </a:pPr>
             <a:r>
               <a:rPr lang="fr-FR" dirty="0" smtClean="0"/>
-              <a:t>Partie 1 du TP !</a:t>
+              <a:t>Part </a:t>
+            </a:r>
+            <a:r>
+              <a:rPr lang="fr-FR" dirty="0" smtClean="0"/>
+              <a:t>1 </a:t>
+            </a:r>
+            <a:r>
+              <a:rPr lang="fr-FR" dirty="0" smtClean="0"/>
+              <a:t>of the </a:t>
+            </a:r>
+            <a:r>
+              <a:rPr lang="fr-FR" dirty="0" err="1" smtClean="0"/>
+              <a:t>lab</a:t>
+            </a:r>
+            <a:r>
+              <a:rPr lang="fr-FR" dirty="0" smtClean="0"/>
+              <a:t> </a:t>
+            </a:r>
+            <a:r>
+              <a:rPr lang="fr-FR" dirty="0" smtClean="0"/>
+              <a:t>!</a:t>
             </a:r>
             <a:endParaRPr lang="fr-FR" dirty="0"/>
           </a:p>

</xml_diff>